<commit_message>
feat: alertas RAP/ambiente desde import (RN-05/RN-06/RN-27), confirmacion global create/update/delete, tab Correcciones pendientes en Reportes, canonizacion de ambiente y RAP en normalizador, usuario Administrador real, docs contexto v9.8
</commit_message>
<xml_diff>
--- a/docs/ConIns_ERS_Y_Relevantes/CONINS - Contexto general del proyecto.pptx
+++ b/docs/ConIns_ERS_Y_Relevantes/CONINS - Contexto general del proyecto.pptx
@@ -1,30 +1,31 @@
 
 <file path=ppt/presentation.xml><?xml version="1.0" encoding="utf-8"?>
-<p:presentation xmlns:a="http://schemas.openxmlformats.org/drawingml/2006/main" xmlns:r="http://schemas.openxmlformats.org/officeDocument/2006/relationships" xmlns:p="http://schemas.openxmlformats.org/presentationml/2006/main" saveSubsetFonts="true" autoCompressPictures="0" embedTrueTypeFonts="true">
+<p:presentation xmlns:a="http://schemas.openxmlformats.org/drawingml/2006/main" xmlns:r="http://schemas.openxmlformats.org/officeDocument/2006/relationships" xmlns:p="http://schemas.openxmlformats.org/presentationml/2006/main" embedTrueTypeFonts="1" saveSubsetFonts="1" autoCompressPictures="0">
   <p:sldMasterIdLst>
     <p:sldMasterId id="2147483648" r:id="rId1"/>
   </p:sldMasterIdLst>
+  <p:notesMasterIdLst>
+    <p:notesMasterId r:id="rId7"/>
+  </p:notesMasterIdLst>
   <p:sldIdLst>
     <p:sldId id="256" r:id="rId2"/>
     <p:sldId id="257" r:id="rId3"/>
     <p:sldId id="258" r:id="rId4"/>
-    <p:sldId id="259" r:id="rId5"/>
+    <p:sldId id="260" r:id="rId5"/>
+    <p:sldId id="259" r:id="rId6"/>
   </p:sldIdLst>
-  <p:notesMasterIdLst>
-    <p:notesMasterId r:id="rId6"/>
-  </p:notesMasterIdLst>
   <p:sldSz cx="12192000" cy="6858000"/>
   <p:notesSz cx="6858000" cy="12192000"/>
   <p:embeddedFontLst>
     <p:embeddedFont>
-      <p:font typeface="Montserrat"/>
-      <p:regular r:id="rId201314"/>
-      <p:bold r:id="rId301314"/>
+      <p:font typeface="Montserrat" panose="00000500000000000000" pitchFamily="2" charset="0"/>
+      <p:regular r:id="rId8"/>
+      <p:bold r:id="rId9"/>
     </p:embeddedFont>
     <p:embeddedFont>
-      <p:font typeface="Roboto"/>
-      <p:regular r:id="rId201315"/>
-      <p:bold r:id="rId301315"/>
+      <p:font typeface="Roboto" panose="02000000000000000000" pitchFamily="2" charset="0"/>
+      <p:regular r:id="rId10"/>
+      <p:bold r:id="rId11"/>
     </p:embeddedFont>
   </p:embeddedFontLst>
   <p:defaultTextStyle>
@@ -119,6 +120,11 @@
       </a:defRPr>
     </a:lvl9pPr>
   </p:defaultTextStyle>
+  <p:extLst>
+    <p:ext uri="{EFAFB233-063F-42B5-8137-9DF3F51BA10A}">
+      <p15:sldGuideLst xmlns:p15="http://schemas.microsoft.com/office/powerpoint/2012/main"/>
+    </p:ext>
+  </p:extLst>
 </p:presentation>
 </file>
 
@@ -144,234 +150,10 @@
           <a:chExt cx="0" cy="0"/>
         </a:xfrm>
       </p:grpSpPr>
-      <p:sp>
-        <p:nvSpPr>
-          <p:cNvPr id="2" name="Header Placeholder 1"/>
-          <p:cNvSpPr>
-            <a:spLocks noGrp="1"/>
-          </p:cNvSpPr>
-          <p:nvPr>
-            <p:ph type="hdr" sz="quarter"/>
-          </p:nvPr>
-        </p:nvSpPr>
-        <p:spPr>
-          <a:xfrm>
-            <a:off x="0" y="0"/>
-            <a:ext cx="2971800" cy="458788"/>
-          </a:xfrm>
-          <a:prstGeom prst="rect">
-            <a:avLst/>
-          </a:prstGeom>
-        </p:spPr>
-        <p:txBody>
-          <a:bodyPr vert="horz" lIns="91440" tIns="45720" rIns="91440" bIns="45720" rtlCol="0"/>
-          <a:lstStyle>
-            <a:lvl1pPr algn="l">
-              <a:defRPr sz="1200"/>
-            </a:lvl1pPr>
-          </a:lstStyle>
-          <a:p>
-            <a:endParaRPr lang="en-US"/>
-          </a:p>
-        </p:txBody>
-      </p:sp>
-      <p:sp>
-        <p:nvSpPr>
-          <p:cNvPr id="3" name="Date Placeholder 2"/>
-          <p:cNvSpPr>
-            <a:spLocks noGrp="1"/>
-          </p:cNvSpPr>
-          <p:nvPr>
-            <p:ph type="dt" idx="1"/>
-          </p:nvPr>
-        </p:nvSpPr>
-        <p:spPr>
-          <a:xfrm>
-            <a:off x="3884613" y="0"/>
-            <a:ext cx="2971800" cy="458788"/>
-          </a:xfrm>
-          <a:prstGeom prst="rect">
-            <a:avLst/>
-          </a:prstGeom>
-        </p:spPr>
-        <p:txBody>
-          <a:bodyPr vert="horz" lIns="91440" tIns="45720" rIns="91440" bIns="45720" rtlCol="0"/>
-          <a:lstStyle>
-            <a:lvl1pPr algn="r">
-              <a:defRPr sz="1200"/>
-            </a:lvl1pPr>
-          </a:lstStyle>
-          <a:p>
-            <a:fld id="{5282F153-3F37-0F45-9E97-73ACFA13230C}" type="datetimeFigureOut">
-              <a:rPr lang="en-US"/>
-              <a:t>7/23/19</a:t>
-            </a:fld>
-            <a:endParaRPr lang="en-US"/>
-          </a:p>
-        </p:txBody>
-      </p:sp>
-      <p:sp>
-        <p:nvSpPr>
-          <p:cNvPr id="4" name="Slide Image Placeholder 3"/>
-          <p:cNvSpPr>
-            <a:spLocks noGrp="1" noRot="1" noChangeAspect="1"/>
-          </p:cNvSpPr>
-          <p:nvPr>
-            <p:ph type="sldImg" idx="2"/>
-          </p:nvPr>
-        </p:nvSpPr>
-        <p:spPr>
-          <a:xfrm>
-            <a:off x="685800" y="1143000"/>
-            <a:ext cx="5486400" cy="3086100"/>
-          </a:xfrm>
-          <a:prstGeom prst="rect">
-            <a:avLst/>
-          </a:prstGeom>
-          <a:noFill/>
-          <a:ln w="12700">
-            <a:solidFill>
-              <a:prstClr val="black"/>
-            </a:solidFill>
-          </a:ln>
-        </p:spPr>
-        <p:txBody>
-          <a:bodyPr vert="horz" lIns="91440" tIns="45720" rIns="91440" bIns="45720" rtlCol="0" anchor="ctr"/>
-          <a:lstStyle/>
-          <a:p>
-            <a:endParaRPr lang="en-US"/>
-          </a:p>
-        </p:txBody>
-      </p:sp>
-      <p:sp>
-        <p:nvSpPr>
-          <p:cNvPr id="5" name="Notes Placeholder 4"/>
-          <p:cNvSpPr>
-            <a:spLocks noGrp="1"/>
-          </p:cNvSpPr>
-          <p:nvPr>
-            <p:ph type="body" sz="quarter" idx="3"/>
-          </p:nvPr>
-        </p:nvSpPr>
-        <p:spPr>
-          <a:xfrm>
-            <a:off x="685800" y="4400550"/>
-            <a:ext cx="5486400" cy="3600450"/>
-          </a:xfrm>
-          <a:prstGeom prst="rect">
-            <a:avLst/>
-          </a:prstGeom>
-        </p:spPr>
-        <p:txBody>
-          <a:bodyPr vert="horz" lIns="91440" tIns="45720" rIns="91440" bIns="45720" rtlCol="0"/>
-          <a:lstStyle/>
-          <a:p>
-            <a:pPr lvl="0"/>
-            <a:r>
-              <a:rPr lang="en-US"/>
-              <a:t>Click to edit Master text styles</a:t>
-            </a:r>
-          </a:p>
-          <a:p>
-            <a:pPr lvl="1"/>
-            <a:r>
-              <a:rPr lang="en-US"/>
-              <a:t>Second level</a:t>
-            </a:r>
-          </a:p>
-          <a:p>
-            <a:pPr lvl="2"/>
-            <a:r>
-              <a:rPr lang="en-US"/>
-              <a:t>Third level</a:t>
-            </a:r>
-          </a:p>
-          <a:p>
-            <a:pPr lvl="3"/>
-            <a:r>
-              <a:rPr lang="en-US"/>
-              <a:t>Fourth level</a:t>
-            </a:r>
-          </a:p>
-          <a:p>
-            <a:pPr lvl="4"/>
-            <a:r>
-              <a:rPr lang="en-US"/>
-              <a:t>Fifth level</a:t>
-            </a:r>
-          </a:p>
-        </p:txBody>
-      </p:sp>
-      <p:sp>
-        <p:nvSpPr>
-          <p:cNvPr id="6" name="Footer Placeholder 5"/>
-          <p:cNvSpPr>
-            <a:spLocks noGrp="1"/>
-          </p:cNvSpPr>
-          <p:nvPr>
-            <p:ph type="ftr" sz="quarter" idx="4"/>
-          </p:nvPr>
-        </p:nvSpPr>
-        <p:spPr>
-          <a:xfrm>
-            <a:off x="0" y="8685213"/>
-            <a:ext cx="2971800" cy="458787"/>
-          </a:xfrm>
-          <a:prstGeom prst="rect">
-            <a:avLst/>
-          </a:prstGeom>
-        </p:spPr>
-        <p:txBody>
-          <a:bodyPr vert="horz" lIns="91440" tIns="45720" rIns="91440" bIns="45720" rtlCol="0" anchor="b"/>
-          <a:lstStyle>
-            <a:lvl1pPr algn="l">
-              <a:defRPr sz="1200"/>
-            </a:lvl1pPr>
-          </a:lstStyle>
-          <a:p>
-            <a:endParaRPr lang="en-US"/>
-          </a:p>
-        </p:txBody>
-      </p:sp>
-      <p:sp>
-        <p:nvSpPr>
-          <p:cNvPr id="7" name="Slide Number Placeholder 6"/>
-          <p:cNvSpPr>
-            <a:spLocks noGrp="1"/>
-          </p:cNvSpPr>
-          <p:nvPr>
-            <p:ph type="sldNum" sz="quarter" idx="5"/>
-          </p:nvPr>
-        </p:nvSpPr>
-        <p:spPr>
-          <a:xfrm>
-            <a:off x="3884613" y="8685213"/>
-            <a:ext cx="2971800" cy="458787"/>
-          </a:xfrm>
-          <a:prstGeom prst="rect">
-            <a:avLst/>
-          </a:prstGeom>
-        </p:spPr>
-        <p:txBody>
-          <a:bodyPr vert="horz" lIns="91440" tIns="45720" rIns="91440" bIns="45720" rtlCol="0" anchor="b"/>
-          <a:lstStyle>
-            <a:lvl1pPr algn="r">
-              <a:defRPr sz="1200"/>
-            </a:lvl1pPr>
-          </a:lstStyle>
-          <a:p>
-            <a:fld id="{CE5E9CC1-C706-0F49-92D6-E571CC5EEA8F}" type="slidenum">
-              <a:rPr lang="en-US"/>
-              <a:t>‹#›</a:t>
-            </a:fld>
-            <a:endParaRPr lang="en-US"/>
-          </a:p>
-        </p:txBody>
-      </p:sp>
     </p:spTree>
     <p:extLst>
       <p:ext uri="{BB962C8B-B14F-4D97-AF65-F5344CB8AC3E}">
-        <p14:creationId xmlns:p14="http://schemas.microsoft.com/office/powerpoint/2010/main" val="1024086991"/>
+        <p14:creationId xmlns:p14="http://schemas.microsoft.com/office/powerpoint/2010/main" val="1762760272"/>
       </p:ext>
     </p:extLst>
   </p:cSld>
@@ -515,10 +297,6 @@
           <a:bodyPr/>
           <a:lstStyle/>
           <a:p>
-            <a:r>
-              <a:rPr lang="en-US" dirty="0"/>
-              <a:t/>
-            </a:r>
             <a:endParaRPr lang="en-US" dirty="0"/>
           </a:p>
         </p:txBody>
@@ -603,10 +381,6 @@
           <a:bodyPr/>
           <a:lstStyle/>
           <a:p>
-            <a:r>
-              <a:rPr lang="en-US" dirty="0"/>
-              <a:t/>
-            </a:r>
             <a:endParaRPr lang="en-US" dirty="0"/>
           </a:p>
         </p:txBody>
@@ -691,10 +465,6 @@
           <a:bodyPr/>
           <a:lstStyle/>
           <a:p>
-            <a:r>
-              <a:rPr lang="en-US" dirty="0"/>
-              <a:t/>
-            </a:r>
             <a:endParaRPr lang="en-US" dirty="0"/>
           </a:p>
         </p:txBody>
@@ -779,10 +549,6 @@
           <a:bodyPr/>
           <a:lstStyle/>
           <a:p>
-            <a:r>
-              <a:rPr lang="en-US" dirty="0"/>
-              <a:t/>
-            </a:r>
             <a:endParaRPr lang="en-US" dirty="0"/>
           </a:p>
         </p:txBody>
@@ -804,7 +570,7 @@
           <a:p>
             <a:fld id="{F7021451-1387-4CA6-816F-3879F97B5CBC}" type="slidenum">
               <a:rPr lang="en-US"/>
-              <a:t>4</a:t>
+              <a:t>5</a:t>
             </a:fld>
             <a:endParaRPr lang="en-US"/>
           </a:p>
@@ -856,6 +622,11 @@
 <file path=ppt/slideMasters/slideMaster1.xml><?xml version="1.0" encoding="utf-8"?>
 <p:sldMaster xmlns:a="http://schemas.openxmlformats.org/drawingml/2006/main" xmlns:r="http://schemas.openxmlformats.org/officeDocument/2006/relationships" xmlns:p="http://schemas.openxmlformats.org/presentationml/2006/main">
   <p:cSld>
+    <p:bg>
+      <p:bgRef idx="1001">
+        <a:schemeClr val="bg1"/>
+      </p:bgRef>
+    </p:bg>
     <p:spTree>
       <p:nvGrpSpPr>
         <p:cNvPr id="1" name=""/>
@@ -1149,14 +920,14 @@
       </p:grpSpPr>
       <p:pic>
         <p:nvPicPr>
-          <p:cNvPr id="2" name="SK-1-img-1" descr="preencoded.png">    </p:cNvPr>
+          <p:cNvPr id="2" name="SK-1-img-1" descr="preencoded.png"/>
           <p:cNvPicPr>
             <a:picLocks noChangeAspect="1"/>
           </p:cNvPicPr>
           <p:nvPr/>
         </p:nvPicPr>
         <p:blipFill>
-          <a:blip r:embed="rId1"/>
+          <a:blip r:embed="rId3"/>
           <a:stretch>
             <a:fillRect/>
           </a:stretch>
@@ -1173,14 +944,14 @@
       </p:pic>
       <p:pic>
         <p:nvPicPr>
-          <p:cNvPr id="3" name="SK-1-img-2" descr="preencoded.png">    </p:cNvPr>
+          <p:cNvPr id="3" name="SK-1-img-2" descr="preencoded.png"/>
           <p:cNvPicPr>
             <a:picLocks noChangeAspect="1"/>
           </p:cNvPicPr>
           <p:nvPr/>
         </p:nvPicPr>
         <p:blipFill>
-          <a:blip r:embed="rId2"/>
+          <a:blip r:embed="rId4"/>
           <a:stretch>
             <a:fillRect/>
           </a:stretch>
@@ -1213,10 +984,10 @@
           <a:ln/>
         </p:spPr>
         <p:txBody>
-          <a:bodyPr wrap="none" lIns="0" tIns="0" rIns="0" bIns="0" rtlCol="0" anchor="ctr" vert="horz"/>
-          <a:lstStyle/>
-          <a:p>
-            <a:pPr algn="ctr" indent="0" marL="0">
+          <a:bodyPr vert="horz" wrap="none" lIns="0" tIns="0" rIns="0" bIns="0" rtlCol="0" anchor="ctr"/>
+          <a:lstStyle/>
+          <a:p>
+            <a:pPr marL="0" indent="0" algn="ctr">
               <a:buNone/>
             </a:pPr>
             <a:r>
@@ -1252,10 +1023,10 @@
           <a:ln/>
         </p:spPr>
         <p:txBody>
-          <a:bodyPr wrap="none" lIns="0" tIns="0" rIns="0" bIns="0" rtlCol="0" anchor="ctr" vert="horz"/>
-          <a:lstStyle/>
-          <a:p>
-            <a:pPr algn="ctr" indent="0" marL="0">
+          <a:bodyPr vert="horz" wrap="none" lIns="0" tIns="0" rIns="0" bIns="0" rtlCol="0" anchor="ctr"/>
+          <a:lstStyle/>
+          <a:p>
+            <a:pPr marL="0" indent="0" algn="ctr">
               <a:buNone/>
             </a:pPr>
             <a:r>
@@ -1291,10 +1062,10 @@
           <a:ln/>
         </p:spPr>
         <p:txBody>
-          <a:bodyPr wrap="none" lIns="0" tIns="0" rIns="0" bIns="0" rtlCol="0" anchor="ctr" vert="horz"/>
-          <a:lstStyle/>
-          <a:p>
-            <a:pPr algn="ctr" indent="0" marL="0">
+          <a:bodyPr vert="horz" wrap="none" lIns="0" tIns="0" rIns="0" bIns="0" rtlCol="0" anchor="ctr"/>
+          <a:lstStyle/>
+          <a:p>
+            <a:pPr marL="0" indent="0" algn="ctr">
               <a:buNone/>
             </a:pPr>
             <a:r>
@@ -1330,10 +1101,10 @@
           <a:ln/>
         </p:spPr>
         <p:txBody>
-          <a:bodyPr wrap="none" lIns="0" tIns="0" rIns="0" bIns="0" rtlCol="0" anchor="ctr" vert="horz"/>
-          <a:lstStyle/>
-          <a:p>
-            <a:pPr algn="ctr" indent="0" marL="0">
+          <a:bodyPr vert="horz" wrap="none" lIns="0" tIns="0" rIns="0" bIns="0" rtlCol="0" anchor="ctr"/>
+          <a:lstStyle/>
+          <a:p>
+            <a:pPr marL="0" indent="0" algn="ctr">
               <a:lnSpc>
                 <a:spcPts val="2925"/>
               </a:lnSpc>
@@ -1353,7 +1124,7 @@
             <a:endParaRPr lang="en-US" sz="2250" dirty="0"/>
           </a:p>
           <a:p>
-            <a:pPr algn="ctr" indent="0" marL="0">
+            <a:pPr marL="0" indent="0" algn="ctr">
               <a:lnSpc>
                 <a:spcPts val="2925"/>
               </a:lnSpc>
@@ -1392,10 +1163,10 @@
           <a:ln/>
         </p:spPr>
         <p:txBody>
-          <a:bodyPr wrap="none" lIns="0" tIns="0" rIns="0" bIns="0" rtlCol="0" anchor="ctr" vert="horz"/>
-          <a:lstStyle/>
-          <a:p>
-            <a:pPr algn="ctr" indent="0" marL="0">
+          <a:bodyPr vert="horz" wrap="none" lIns="0" tIns="0" rIns="0" bIns="0" rtlCol="0" anchor="ctr"/>
+          <a:lstStyle/>
+          <a:p>
+            <a:pPr marL="0" indent="0" algn="ctr">
               <a:buNone/>
             </a:pPr>
             <a:r>
@@ -1407,7 +1178,7 @@
                 <a:ea typeface="Montserrat" pitchFamily="34" charset="-122"/>
                 <a:cs typeface="Montserrat" pitchFamily="34" charset="-120"/>
               </a:rPr>
-              <a:t>Contexto general del proyecto · SENA CDMC · Julio 2026</a:t>
+              <a:t>Contexto general del proyecto · SENA CDMC · Agosto 2026</a:t>
             </a:r>
             <a:endParaRPr lang="en-US" sz="1200" dirty="0"/>
           </a:p>
@@ -1440,55 +1211,7 @@
       </p:grpSpPr>
       <p:pic>
         <p:nvPicPr>
-          <p:cNvPr id="2" name="SK-2-img-1" descr="preencoded.png">    </p:cNvPr>
-          <p:cNvPicPr>
-            <a:picLocks noChangeAspect="1"/>
-          </p:cNvPicPr>
-          <p:nvPr/>
-        </p:nvPicPr>
-        <p:blipFill>
-          <a:blip r:embed="rId1"/>
-          <a:stretch>
-            <a:fillRect/>
-          </a:stretch>
-        </p:blipFill>
-        <p:spPr>
-          <a:xfrm>
-            <a:off x="0" y="0"/>
-            <a:ext cx="12192000" cy="6858000"/>
-          </a:xfrm>
-          <a:prstGeom prst="rect">
-            <a:avLst/>
-          </a:prstGeom>
-        </p:spPr>
-      </p:pic>
-      <p:pic>
-        <p:nvPicPr>
-          <p:cNvPr id="3" name="SK-2-img-2" descr="preencoded.png">    </p:cNvPr>
-          <p:cNvPicPr>
-            <a:picLocks noChangeAspect="1"/>
-          </p:cNvPicPr>
-          <p:nvPr/>
-        </p:nvPicPr>
-        <p:blipFill>
-          <a:blip r:embed="rId2"/>
-          <a:stretch>
-            <a:fillRect/>
-          </a:stretch>
-        </p:blipFill>
-        <p:spPr>
-          <a:xfrm>
-            <a:off x="548580" y="397669"/>
-            <a:ext cx="1036290" cy="377130"/>
-          </a:xfrm>
-          <a:prstGeom prst="rect">
-            <a:avLst/>
-          </a:prstGeom>
-        </p:spPr>
-      </p:pic>
-      <p:pic>
-        <p:nvPicPr>
-          <p:cNvPr id="4" name="SK-2-img-3" descr="preencoded.png">    </p:cNvPr>
+          <p:cNvPr id="2" name="SK-2-img-1" descr="preencoded.png"/>
           <p:cNvPicPr>
             <a:picLocks noChangeAspect="1"/>
           </p:cNvPicPr>
@@ -1502,8 +1225,8 @@
         </p:blipFill>
         <p:spPr>
           <a:xfrm>
-            <a:off x="548580" y="1277541"/>
-            <a:ext cx="11070282" cy="969615"/>
+            <a:off x="0" y="0"/>
+            <a:ext cx="12192000" cy="6858000"/>
           </a:xfrm>
           <a:prstGeom prst="rect">
             <a:avLst/>
@@ -1512,7 +1235,7 @@
       </p:pic>
       <p:pic>
         <p:nvPicPr>
-          <p:cNvPr id="5" name="SK-2-img-4" descr="preencoded.png">    </p:cNvPr>
+          <p:cNvPr id="3" name="SK-2-img-2" descr="preencoded.png"/>
           <p:cNvPicPr>
             <a:picLocks noChangeAspect="1"/>
           </p:cNvPicPr>
@@ -1526,8 +1249,8 @@
         </p:blipFill>
         <p:spPr>
           <a:xfrm>
-            <a:off x="548580" y="3442692"/>
-            <a:ext cx="5364361" cy="2818507"/>
+            <a:off x="548580" y="397669"/>
+            <a:ext cx="1036290" cy="377130"/>
           </a:xfrm>
           <a:prstGeom prst="rect">
             <a:avLst/>
@@ -1536,7 +1259,7 @@
       </p:pic>
       <p:pic>
         <p:nvPicPr>
-          <p:cNvPr id="6" name="SK-2-img-5" descr="preencoded.png">    </p:cNvPr>
+          <p:cNvPr id="4" name="SK-2-img-3" descr="preencoded.png"/>
           <p:cNvPicPr>
             <a:picLocks noChangeAspect="1"/>
           </p:cNvPicPr>
@@ -1550,8 +1273,8 @@
         </p:blipFill>
         <p:spPr>
           <a:xfrm>
-            <a:off x="6278761" y="3429000"/>
-            <a:ext cx="5339953" cy="2771924"/>
+            <a:off x="548580" y="1277541"/>
+            <a:ext cx="11070282" cy="969615"/>
           </a:xfrm>
           <a:prstGeom prst="rect">
             <a:avLst/>
@@ -1560,7 +1283,7 @@
       </p:pic>
       <p:pic>
         <p:nvPicPr>
-          <p:cNvPr id="7" name="SK-2-img-6" descr="preencoded.png">    </p:cNvPr>
+          <p:cNvPr id="5" name="SK-2-img-4" descr="preencoded.png"/>
           <p:cNvPicPr>
             <a:picLocks noChangeAspect="1"/>
           </p:cNvPicPr>
@@ -1574,6 +1297,54 @@
         </p:blipFill>
         <p:spPr>
           <a:xfrm>
+            <a:off x="548580" y="3442692"/>
+            <a:ext cx="5364361" cy="2818507"/>
+          </a:xfrm>
+          <a:prstGeom prst="rect">
+            <a:avLst/>
+          </a:prstGeom>
+        </p:spPr>
+      </p:pic>
+      <p:pic>
+        <p:nvPicPr>
+          <p:cNvPr id="6" name="SK-2-img-5" descr="preencoded.png"/>
+          <p:cNvPicPr>
+            <a:picLocks noChangeAspect="1"/>
+          </p:cNvPicPr>
+          <p:nvPr/>
+        </p:nvPicPr>
+        <p:blipFill>
+          <a:blip r:embed="rId7"/>
+          <a:stretch>
+            <a:fillRect/>
+          </a:stretch>
+        </p:blipFill>
+        <p:spPr>
+          <a:xfrm>
+            <a:off x="6278761" y="3429000"/>
+            <a:ext cx="5339953" cy="2771924"/>
+          </a:xfrm>
+          <a:prstGeom prst="rect">
+            <a:avLst/>
+          </a:prstGeom>
+        </p:spPr>
+      </p:pic>
+      <p:pic>
+        <p:nvPicPr>
+          <p:cNvPr id="7" name="SK-2-img-6" descr="preencoded.png"/>
+          <p:cNvPicPr>
+            <a:picLocks noChangeAspect="1"/>
+          </p:cNvPicPr>
+          <p:nvPr/>
+        </p:nvPicPr>
+        <p:blipFill>
+          <a:blip r:embed="rId8"/>
+          <a:stretch>
+            <a:fillRect/>
+          </a:stretch>
+        </p:blipFill>
+        <p:spPr>
+          <a:xfrm>
             <a:off x="10241161" y="5109121"/>
             <a:ext cx="1950690" cy="1748730"/>
           </a:xfrm>
@@ -1600,10 +1371,10 @@
           <a:ln/>
         </p:spPr>
         <p:txBody>
-          <a:bodyPr wrap="none" lIns="0" tIns="0" rIns="0" bIns="0" rtlCol="0" anchor="ctr" vert="horz"/>
-          <a:lstStyle/>
-          <a:p>
-            <a:pPr algn="ctr" indent="0" marL="0">
+          <a:bodyPr vert="horz" wrap="none" lIns="0" tIns="0" rIns="0" bIns="0" rtlCol="0" anchor="ctr"/>
+          <a:lstStyle/>
+          <a:p>
+            <a:pPr marL="0" indent="0" algn="ctr">
               <a:buNone/>
             </a:pPr>
             <a:r>
@@ -1639,10 +1410,10 @@
           <a:ln/>
         </p:spPr>
         <p:txBody>
-          <a:bodyPr wrap="none" lIns="0" tIns="0" rIns="0" bIns="0" rtlCol="0" anchor="ctr" vert="horz"/>
-          <a:lstStyle/>
-          <a:p>
-            <a:pPr algn="l" indent="0" marL="0">
+          <a:bodyPr vert="horz" wrap="none" lIns="0" tIns="0" rIns="0" bIns="0" rtlCol="0" anchor="ctr"/>
+          <a:lstStyle/>
+          <a:p>
+            <a:pPr marL="0" indent="0" algn="l">
               <a:buNone/>
             </a:pPr>
             <a:r>
@@ -1675,10 +1446,10 @@
           <a:ln/>
         </p:spPr>
         <p:txBody>
-          <a:bodyPr wrap="none" lIns="0" tIns="0" rIns="0" bIns="0" rtlCol="0" anchor="ctr" vert="horz"/>
-          <a:lstStyle/>
-          <a:p>
-            <a:pPr algn="ctr" indent="0" marL="0">
+          <a:bodyPr vert="horz" wrap="none" lIns="0" tIns="0" rIns="0" bIns="0" rtlCol="0" anchor="ctr"/>
+          <a:lstStyle/>
+          <a:p>
+            <a:pPr marL="0" indent="0" algn="ctr">
               <a:buNone/>
             </a:pPr>
             <a:r>
@@ -1711,10 +1482,10 @@
           <a:ln/>
         </p:spPr>
         <p:txBody>
-          <a:bodyPr wrap="none" lIns="0" tIns="0" rIns="0" bIns="0" rtlCol="0" anchor="ctr" vert="horz"/>
-          <a:lstStyle/>
-          <a:p>
-            <a:pPr algn="ctr" indent="0" marL="0">
+          <a:bodyPr vert="horz" wrap="none" lIns="0" tIns="0" rIns="0" bIns="0" rtlCol="0" anchor="ctr"/>
+          <a:lstStyle/>
+          <a:p>
+            <a:pPr marL="0" indent="0" algn="ctr">
               <a:buNone/>
             </a:pPr>
             <a:r>
@@ -1750,10 +1521,10 @@
           <a:ln/>
         </p:spPr>
         <p:txBody>
-          <a:bodyPr wrap="none" lIns="0" tIns="0" rIns="0" bIns="0" rtlCol="0" anchor="ctr" vert="horz"/>
-          <a:lstStyle/>
-          <a:p>
-            <a:pPr algn="l" indent="0" marL="0">
+          <a:bodyPr vert="horz" wrap="none" lIns="0" tIns="0" rIns="0" bIns="0" rtlCol="0" anchor="ctr"/>
+          <a:lstStyle/>
+          <a:p>
+            <a:pPr marL="0" indent="0" algn="l">
               <a:buNone/>
             </a:pPr>
             <a:r>
@@ -1789,10 +1560,10 @@
           <a:ln/>
         </p:spPr>
         <p:txBody>
-          <a:bodyPr wrap="none" lIns="0" tIns="0" rIns="0" bIns="0" rtlCol="0" anchor="ctr" vert="horz"/>
-          <a:lstStyle/>
-          <a:p>
-            <a:pPr algn="l" indent="0" marL="0">
+          <a:bodyPr vert="horz" wrap="none" lIns="0" tIns="0" rIns="0" bIns="0" rtlCol="0" anchor="ctr"/>
+          <a:lstStyle/>
+          <a:p>
+            <a:pPr marL="0" indent="0" algn="l">
               <a:buNone/>
             </a:pPr>
             <a:r>
@@ -1828,10 +1599,10 @@
           <a:ln/>
         </p:spPr>
         <p:txBody>
-          <a:bodyPr wrap="none" lIns="0" tIns="0" rIns="0" bIns="0" rtlCol="0" anchor="ctr" vert="horz"/>
-          <a:lstStyle/>
-          <a:p>
-            <a:pPr algn="l" indent="0" marL="0">
+          <a:bodyPr vert="horz" wrap="none" lIns="0" tIns="0" rIns="0" bIns="0" rtlCol="0" anchor="ctr"/>
+          <a:lstStyle/>
+          <a:p>
+            <a:pPr marL="0" indent="0" algn="l">
               <a:buNone/>
             </a:pPr>
             <a:r>
@@ -1867,10 +1638,10 @@
           <a:ln/>
         </p:spPr>
         <p:txBody>
-          <a:bodyPr wrap="none" lIns="0" tIns="0" rIns="0" bIns="0" rtlCol="0" anchor="ctr" vert="horz"/>
-          <a:lstStyle/>
-          <a:p>
-            <a:pPr algn="l" indent="0" marL="0">
+          <a:bodyPr vert="horz" wrap="none" lIns="0" tIns="0" rIns="0" bIns="0" rtlCol="0" anchor="ctr"/>
+          <a:lstStyle/>
+          <a:p>
+            <a:pPr marL="0" indent="0" algn="l">
               <a:buNone/>
             </a:pPr>
             <a:r>
@@ -1882,7 +1653,7 @@
                 <a:ea typeface="Roboto" pitchFamily="34" charset="-122"/>
                 <a:cs typeface="Roboto" pitchFamily="34" charset="-120"/>
               </a:rPr>
-              <a:t>✓ Avisar posibles cruces o sobrecargas</a:t>
+              <a:t>✓ Avisar cruces y sobrecargas de horas</a:t>
             </a:r>
             <a:endParaRPr lang="en-US" sz="2100" dirty="0"/>
           </a:p>
@@ -1906,10 +1677,10 @@
           <a:ln/>
         </p:spPr>
         <p:txBody>
-          <a:bodyPr wrap="none" lIns="0" tIns="0" rIns="0" bIns="0" rtlCol="0" anchor="ctr" vert="horz"/>
-          <a:lstStyle/>
-          <a:p>
-            <a:pPr algn="l" indent="0" marL="0">
+          <a:bodyPr vert="horz" wrap="none" lIns="0" tIns="0" rIns="0" bIns="0" rtlCol="0" anchor="ctr"/>
+          <a:lstStyle/>
+          <a:p>
+            <a:pPr marL="0" indent="0" algn="l">
               <a:buNone/>
             </a:pPr>
             <a:r>
@@ -1921,7 +1692,7 @@
                 <a:ea typeface="Roboto" pitchFamily="34" charset="-122"/>
                 <a:cs typeface="Roboto" pitchFamily="34" charset="-120"/>
               </a:rPr>
-              <a:t>✓ Consultar y exportar la malla</a:t>
+              <a:t>✓ Consultar y exportar la malla (PDF)</a:t>
             </a:r>
             <a:endParaRPr lang="en-US" sz="2100" dirty="0"/>
           </a:p>
@@ -1945,10 +1716,10 @@
           <a:ln/>
         </p:spPr>
         <p:txBody>
-          <a:bodyPr wrap="none" lIns="0" tIns="0" rIns="0" bIns="0" rtlCol="0" anchor="ctr" vert="horz"/>
-          <a:lstStyle/>
-          <a:p>
-            <a:pPr algn="l" indent="0" marL="0">
+          <a:bodyPr vert="horz" wrap="none" lIns="0" tIns="0" rIns="0" bIns="0" rtlCol="0" anchor="ctr"/>
+          <a:lstStyle/>
+          <a:p>
+            <a:pPr marL="0" indent="0" algn="l">
               <a:buNone/>
             </a:pPr>
             <a:r>
@@ -1984,10 +1755,10 @@
           <a:ln/>
         </p:spPr>
         <p:txBody>
-          <a:bodyPr wrap="none" lIns="0" tIns="0" rIns="0" bIns="0" rtlCol="0" anchor="ctr" vert="horz"/>
-          <a:lstStyle/>
-          <a:p>
-            <a:pPr algn="l" indent="0" marL="0">
+          <a:bodyPr vert="horz" wrap="none" lIns="0" tIns="0" rIns="0" bIns="0" rtlCol="0" anchor="ctr"/>
+          <a:lstStyle/>
+          <a:p>
+            <a:pPr marL="0" indent="0" algn="l">
               <a:buNone/>
             </a:pPr>
             <a:r>
@@ -2023,10 +1794,10 @@
           <a:ln/>
         </p:spPr>
         <p:txBody>
-          <a:bodyPr wrap="none" lIns="0" tIns="0" rIns="0" bIns="0" rtlCol="0" anchor="ctr" vert="horz"/>
-          <a:lstStyle/>
-          <a:p>
-            <a:pPr algn="l" indent="0" marL="0">
+          <a:bodyPr vert="horz" wrap="none" lIns="0" tIns="0" rIns="0" bIns="0" rtlCol="0" anchor="ctr"/>
+          <a:lstStyle/>
+          <a:p>
+            <a:pPr marL="0" indent="0" algn="l">
               <a:buNone/>
             </a:pPr>
             <a:r>
@@ -2062,10 +1833,10 @@
           <a:ln/>
         </p:spPr>
         <p:txBody>
-          <a:bodyPr wrap="none" lIns="0" tIns="0" rIns="0" bIns="0" rtlCol="0" anchor="ctr" vert="horz"/>
-          <a:lstStyle/>
-          <a:p>
-            <a:pPr algn="l" indent="0" marL="0">
+          <a:bodyPr vert="horz" wrap="none" lIns="0" tIns="0" rIns="0" bIns="0" rtlCol="0" anchor="ctr"/>
+          <a:lstStyle/>
+          <a:p>
+            <a:pPr marL="0" indent="0" algn="l">
               <a:buNone/>
             </a:pPr>
             <a:r>
@@ -2110,55 +1881,7 @@
       </p:grpSpPr>
       <p:pic>
         <p:nvPicPr>
-          <p:cNvPr id="2" name="SK-3-img-1" descr="preencoded.png">    </p:cNvPr>
-          <p:cNvPicPr>
-            <a:picLocks noChangeAspect="1"/>
-          </p:cNvPicPr>
-          <p:nvPr/>
-        </p:nvPicPr>
-        <p:blipFill>
-          <a:blip r:embed="rId1"/>
-          <a:stretch>
-            <a:fillRect/>
-          </a:stretch>
-        </p:blipFill>
-        <p:spPr>
-          <a:xfrm>
-            <a:off x="0" y="0"/>
-            <a:ext cx="12192000" cy="6858000"/>
-          </a:xfrm>
-          <a:prstGeom prst="rect">
-            <a:avLst/>
-          </a:prstGeom>
-        </p:spPr>
-      </p:pic>
-      <p:pic>
-        <p:nvPicPr>
-          <p:cNvPr id="3" name="SK-3-img-2" descr="preencoded.png">    </p:cNvPr>
-          <p:cNvPicPr>
-            <a:picLocks noChangeAspect="1"/>
-          </p:cNvPicPr>
-          <p:nvPr/>
-        </p:nvPicPr>
-        <p:blipFill>
-          <a:blip r:embed="rId2"/>
-          <a:stretch>
-            <a:fillRect/>
-          </a:stretch>
-        </p:blipFill>
-        <p:spPr>
-          <a:xfrm>
-            <a:off x="548580" y="377130"/>
-            <a:ext cx="889992" cy="411361"/>
-          </a:xfrm>
-          <a:prstGeom prst="rect">
-            <a:avLst/>
-          </a:prstGeom>
-        </p:spPr>
-      </p:pic>
-      <p:pic>
-        <p:nvPicPr>
-          <p:cNvPr id="4" name="SK-3-img-3" descr="preencoded.png">    </p:cNvPr>
+          <p:cNvPr id="2" name="SK-3-img-1" descr="preencoded.png"/>
           <p:cNvPicPr>
             <a:picLocks noChangeAspect="1"/>
           </p:cNvPicPr>
@@ -2172,8 +1895,8 @@
         </p:blipFill>
         <p:spPr>
           <a:xfrm>
-            <a:off x="548580" y="1412677"/>
-            <a:ext cx="2694384" cy="1803648"/>
+            <a:off x="0" y="0"/>
+            <a:ext cx="12192000" cy="6858000"/>
           </a:xfrm>
           <a:prstGeom prst="rect">
             <a:avLst/>
@@ -2182,7 +1905,7 @@
       </p:pic>
       <p:pic>
         <p:nvPicPr>
-          <p:cNvPr id="5" name="SK-3-img-4" descr="preencoded.png">    </p:cNvPr>
+          <p:cNvPr id="3" name="SK-3-img-2" descr="preencoded.png"/>
           <p:cNvPicPr>
             <a:picLocks noChangeAspect="1"/>
           </p:cNvPicPr>
@@ -2196,8 +1919,8 @@
         </p:blipFill>
         <p:spPr>
           <a:xfrm>
-            <a:off x="3401467" y="1398984"/>
-            <a:ext cx="2694384" cy="1782961"/>
+            <a:off x="548580" y="377130"/>
+            <a:ext cx="889992" cy="411361"/>
           </a:xfrm>
           <a:prstGeom prst="rect">
             <a:avLst/>
@@ -2206,7 +1929,7 @@
       </p:pic>
       <p:pic>
         <p:nvPicPr>
-          <p:cNvPr id="6" name="SK-3-img-5" descr="preencoded.png">    </p:cNvPr>
+          <p:cNvPr id="4" name="SK-3-img-3" descr="preencoded.png"/>
           <p:cNvPicPr>
             <a:picLocks noChangeAspect="1"/>
           </p:cNvPicPr>
@@ -2220,8 +1943,8 @@
         </p:blipFill>
         <p:spPr>
           <a:xfrm>
-            <a:off x="6254353" y="1398984"/>
-            <a:ext cx="2694384" cy="1782961"/>
+            <a:off x="548580" y="1412677"/>
+            <a:ext cx="2694384" cy="1803648"/>
           </a:xfrm>
           <a:prstGeom prst="rect">
             <a:avLst/>
@@ -2230,7 +1953,7 @@
       </p:pic>
       <p:pic>
         <p:nvPicPr>
-          <p:cNvPr id="7" name="SK-3-img-6" descr="preencoded.png">    </p:cNvPr>
+          <p:cNvPr id="5" name="SK-3-img-4" descr="preencoded.png"/>
           <p:cNvPicPr>
             <a:picLocks noChangeAspect="1"/>
           </p:cNvPicPr>
@@ -2244,8 +1967,8 @@
         </p:blipFill>
         <p:spPr>
           <a:xfrm>
-            <a:off x="548580" y="3380929"/>
-            <a:ext cx="2694384" cy="1686967"/>
+            <a:off x="3401467" y="1398984"/>
+            <a:ext cx="2694384" cy="1782961"/>
           </a:xfrm>
           <a:prstGeom prst="rect">
             <a:avLst/>
@@ -2254,7 +1977,7 @@
       </p:pic>
       <p:pic>
         <p:nvPicPr>
-          <p:cNvPr id="8" name="SK-3-img-7" descr="preencoded.png">    </p:cNvPr>
+          <p:cNvPr id="6" name="SK-3-img-5" descr="preencoded.png"/>
           <p:cNvPicPr>
             <a:picLocks noChangeAspect="1"/>
           </p:cNvPicPr>
@@ -2268,8 +1991,8 @@
         </p:blipFill>
         <p:spPr>
           <a:xfrm>
-            <a:off x="3401467" y="3380929"/>
-            <a:ext cx="2694384" cy="1680121"/>
+            <a:off x="6254353" y="1398984"/>
+            <a:ext cx="2694384" cy="1782961"/>
           </a:xfrm>
           <a:prstGeom prst="rect">
             <a:avLst/>
@@ -2278,7 +2001,7 @@
       </p:pic>
       <p:pic>
         <p:nvPicPr>
-          <p:cNvPr id="9" name="SK-3-img-8" descr="preencoded.png">    </p:cNvPr>
+          <p:cNvPr id="7" name="SK-3-img-6" descr="preencoded.png"/>
           <p:cNvPicPr>
             <a:picLocks noChangeAspect="1"/>
           </p:cNvPicPr>
@@ -2292,8 +2015,8 @@
         </p:blipFill>
         <p:spPr>
           <a:xfrm>
-            <a:off x="6254353" y="3380929"/>
-            <a:ext cx="2694384" cy="1673275"/>
+            <a:off x="548580" y="3380929"/>
+            <a:ext cx="2694384" cy="1686967"/>
           </a:xfrm>
           <a:prstGeom prst="rect">
             <a:avLst/>
@@ -2302,7 +2025,7 @@
       </p:pic>
       <p:pic>
         <p:nvPicPr>
-          <p:cNvPr id="10" name="SK-3-img-9" descr="preencoded.png">    </p:cNvPr>
+          <p:cNvPr id="8" name="SK-3-img-7" descr="preencoded.png"/>
           <p:cNvPicPr>
             <a:picLocks noChangeAspect="1"/>
           </p:cNvPicPr>
@@ -2316,8 +2039,8 @@
         </p:blipFill>
         <p:spPr>
           <a:xfrm>
-            <a:off x="8485584" y="3524994"/>
-            <a:ext cx="292596" cy="370284"/>
+            <a:off x="3401467" y="3380929"/>
+            <a:ext cx="2694384" cy="1680121"/>
           </a:xfrm>
           <a:prstGeom prst="rect">
             <a:avLst/>
@@ -2326,7 +2049,7 @@
       </p:pic>
       <p:pic>
         <p:nvPicPr>
-          <p:cNvPr id="11" name="SK-3-img-10" descr="preencoded.png">    </p:cNvPr>
+          <p:cNvPr id="9" name="SK-3-img-8" descr="preencoded.png"/>
           <p:cNvPicPr>
             <a:picLocks noChangeAspect="1"/>
           </p:cNvPicPr>
@@ -2340,8 +2063,8 @@
         </p:blipFill>
         <p:spPr>
           <a:xfrm>
-            <a:off x="6473875" y="3524994"/>
-            <a:ext cx="463153" cy="445740"/>
+            <a:off x="6254353" y="3380929"/>
+            <a:ext cx="2694384" cy="1673275"/>
           </a:xfrm>
           <a:prstGeom prst="rect">
             <a:avLst/>
@@ -2350,7 +2073,7 @@
       </p:pic>
       <p:pic>
         <p:nvPicPr>
-          <p:cNvPr id="12" name="SK-3-img-11" descr="preencoded.png">    </p:cNvPr>
+          <p:cNvPr id="10" name="SK-3-img-9" descr="preencoded.png"/>
           <p:cNvPicPr>
             <a:picLocks noChangeAspect="1"/>
           </p:cNvPicPr>
@@ -2364,8 +2087,8 @@
         </p:blipFill>
         <p:spPr>
           <a:xfrm>
-            <a:off x="4096494" y="3545532"/>
-            <a:ext cx="426690" cy="418207"/>
+            <a:off x="8485584" y="3524994"/>
+            <a:ext cx="292596" cy="370284"/>
           </a:xfrm>
           <a:prstGeom prst="rect">
             <a:avLst/>
@@ -2374,7 +2097,7 @@
       </p:pic>
       <p:pic>
         <p:nvPicPr>
-          <p:cNvPr id="13" name="SK-3-img-12" descr="preencoded.png">    </p:cNvPr>
+          <p:cNvPr id="11" name="SK-3-img-10" descr="preencoded.png"/>
           <p:cNvPicPr>
             <a:picLocks noChangeAspect="1"/>
           </p:cNvPicPr>
@@ -2388,8 +2111,8 @@
         </p:blipFill>
         <p:spPr>
           <a:xfrm>
-            <a:off x="3572173" y="3552379"/>
-            <a:ext cx="511969" cy="411361"/>
+            <a:off x="6473875" y="3524994"/>
+            <a:ext cx="463153" cy="445740"/>
           </a:xfrm>
           <a:prstGeom prst="rect">
             <a:avLst/>
@@ -2398,7 +2121,7 @@
       </p:pic>
       <p:pic>
         <p:nvPicPr>
-          <p:cNvPr id="14" name="SK-3-img-13" descr="preencoded.png">    </p:cNvPr>
+          <p:cNvPr id="12" name="SK-3-img-11" descr="preencoded.png"/>
           <p:cNvPicPr>
             <a:picLocks noChangeAspect="1"/>
           </p:cNvPicPr>
@@ -2412,8 +2135,8 @@
         </p:blipFill>
         <p:spPr>
           <a:xfrm>
-            <a:off x="1267867" y="3538686"/>
-            <a:ext cx="548580" cy="425053"/>
+            <a:off x="4096494" y="3545532"/>
+            <a:ext cx="426690" cy="418207"/>
           </a:xfrm>
           <a:prstGeom prst="rect">
             <a:avLst/>
@@ -2422,7 +2145,7 @@
       </p:pic>
       <p:pic>
         <p:nvPicPr>
-          <p:cNvPr id="15" name="SK-3-img-14" descr="preencoded.png">    </p:cNvPr>
+          <p:cNvPr id="13" name="SK-3-img-12" descr="preencoded.png"/>
           <p:cNvPicPr>
             <a:picLocks noChangeAspect="1"/>
           </p:cNvPicPr>
@@ -2436,8 +2159,8 @@
         </p:blipFill>
         <p:spPr>
           <a:xfrm>
-            <a:off x="719286" y="3559225"/>
-            <a:ext cx="463153" cy="377130"/>
+            <a:off x="3572173" y="3552379"/>
+            <a:ext cx="511969" cy="411361"/>
           </a:xfrm>
           <a:prstGeom prst="rect">
             <a:avLst/>
@@ -2446,7 +2169,7 @@
       </p:pic>
       <p:pic>
         <p:nvPicPr>
-          <p:cNvPr id="16" name="SK-3-img-15" descr="preencoded.png">    </p:cNvPr>
+          <p:cNvPr id="14" name="SK-3-img-13" descr="preencoded.png"/>
           <p:cNvPicPr>
             <a:picLocks noChangeAspect="1"/>
           </p:cNvPicPr>
@@ -2460,8 +2183,8 @@
         </p:blipFill>
         <p:spPr>
           <a:xfrm>
-            <a:off x="6888361" y="1577280"/>
-            <a:ext cx="743694" cy="452586"/>
+            <a:off x="1267867" y="3538686"/>
+            <a:ext cx="548580" cy="425053"/>
           </a:xfrm>
           <a:prstGeom prst="rect">
             <a:avLst/>
@@ -2470,7 +2193,7 @@
       </p:pic>
       <p:pic>
         <p:nvPicPr>
-          <p:cNvPr id="17" name="SK-3-img-16" descr="preencoded.png">    </p:cNvPr>
+          <p:cNvPr id="15" name="SK-3-img-14" descr="preencoded.png"/>
           <p:cNvPicPr>
             <a:picLocks noChangeAspect="1"/>
           </p:cNvPicPr>
@@ -2484,8 +2207,8 @@
         </p:blipFill>
         <p:spPr>
           <a:xfrm>
-            <a:off x="6473875" y="1577280"/>
-            <a:ext cx="365671" cy="445740"/>
+            <a:off x="719286" y="3559225"/>
+            <a:ext cx="463153" cy="377130"/>
           </a:xfrm>
           <a:prstGeom prst="rect">
             <a:avLst/>
@@ -2494,7 +2217,7 @@
       </p:pic>
       <p:pic>
         <p:nvPicPr>
-          <p:cNvPr id="18" name="SK-3-img-17" descr="preencoded.png">    </p:cNvPr>
+          <p:cNvPr id="16" name="SK-3-img-15" descr="preencoded.png"/>
           <p:cNvPicPr>
             <a:picLocks noChangeAspect="1"/>
           </p:cNvPicPr>
@@ -2508,8 +2231,8 @@
         </p:blipFill>
         <p:spPr>
           <a:xfrm>
-            <a:off x="4120753" y="1563588"/>
-            <a:ext cx="621655" cy="479971"/>
+            <a:off x="6888361" y="1577280"/>
+            <a:ext cx="743694" cy="452586"/>
           </a:xfrm>
           <a:prstGeom prst="rect">
             <a:avLst/>
@@ -2518,7 +2241,7 @@
       </p:pic>
       <p:pic>
         <p:nvPicPr>
-          <p:cNvPr id="19" name="SK-3-img-18" descr="preencoded.png">    </p:cNvPr>
+          <p:cNvPr id="17" name="SK-3-img-16" descr="preencoded.png"/>
           <p:cNvPicPr>
             <a:picLocks noChangeAspect="1"/>
           </p:cNvPicPr>
@@ -2532,8 +2255,8 @@
         </p:blipFill>
         <p:spPr>
           <a:xfrm>
-            <a:off x="3572173" y="1577280"/>
-            <a:ext cx="511969" cy="432048"/>
+            <a:off x="6473875" y="1577280"/>
+            <a:ext cx="365671" cy="445740"/>
           </a:xfrm>
           <a:prstGeom prst="rect">
             <a:avLst/>
@@ -2542,7 +2265,7 @@
       </p:pic>
       <p:pic>
         <p:nvPicPr>
-          <p:cNvPr id="20" name="SK-3-img-19" descr="preencoded.png">    </p:cNvPr>
+          <p:cNvPr id="18" name="SK-3-img-17" descr="preencoded.png"/>
           <p:cNvPicPr>
             <a:picLocks noChangeAspect="1"/>
           </p:cNvPicPr>
@@ -2556,6 +2279,54 @@
         </p:blipFill>
         <p:spPr>
           <a:xfrm>
+            <a:off x="4120753" y="1563588"/>
+            <a:ext cx="621655" cy="479971"/>
+          </a:xfrm>
+          <a:prstGeom prst="rect">
+            <a:avLst/>
+          </a:prstGeom>
+        </p:spPr>
+      </p:pic>
+      <p:pic>
+        <p:nvPicPr>
+          <p:cNvPr id="19" name="SK-3-img-18" descr="preencoded.png"/>
+          <p:cNvPicPr>
+            <a:picLocks noChangeAspect="1"/>
+          </p:cNvPicPr>
+          <p:nvPr/>
+        </p:nvPicPr>
+        <p:blipFill>
+          <a:blip r:embed="rId20"/>
+          <a:stretch>
+            <a:fillRect/>
+          </a:stretch>
+        </p:blipFill>
+        <p:spPr>
+          <a:xfrm>
+            <a:off x="3572173" y="1577280"/>
+            <a:ext cx="511969" cy="432048"/>
+          </a:xfrm>
+          <a:prstGeom prst="rect">
+            <a:avLst/>
+          </a:prstGeom>
+        </p:spPr>
+      </p:pic>
+      <p:pic>
+        <p:nvPicPr>
+          <p:cNvPr id="20" name="SK-3-img-19" descr="preencoded.png"/>
+          <p:cNvPicPr>
+            <a:picLocks noChangeAspect="1"/>
+          </p:cNvPicPr>
+          <p:nvPr/>
+        </p:nvPicPr>
+        <p:blipFill>
+          <a:blip r:embed="rId21"/>
+          <a:stretch>
+            <a:fillRect/>
+          </a:stretch>
+        </p:blipFill>
+        <p:spPr>
+          <a:xfrm>
             <a:off x="719286" y="1611511"/>
             <a:ext cx="463153" cy="377130"/>
           </a:xfrm>
@@ -2582,10 +2353,10 @@
           <a:ln/>
         </p:spPr>
         <p:txBody>
-          <a:bodyPr wrap="none" lIns="0" tIns="0" rIns="0" bIns="0" rtlCol="0" anchor="ctr" vert="horz"/>
-          <a:lstStyle/>
-          <a:p>
-            <a:pPr algn="ctr" indent="0" marL="0">
+          <a:bodyPr vert="horz" wrap="none" lIns="0" tIns="0" rIns="0" bIns="0" rtlCol="0" anchor="ctr"/>
+          <a:lstStyle/>
+          <a:p>
+            <a:pPr marL="0" indent="0" algn="ctr">
               <a:buNone/>
             </a:pPr>
             <a:r>
@@ -2621,10 +2392,10 @@
           <a:ln/>
         </p:spPr>
         <p:txBody>
-          <a:bodyPr wrap="none" lIns="0" tIns="0" rIns="0" bIns="0" rtlCol="0" anchor="ctr" vert="horz"/>
-          <a:lstStyle/>
-          <a:p>
-            <a:pPr algn="l" indent="0" marL="0">
+          <a:bodyPr vert="horz" wrap="none" lIns="0" tIns="0" rIns="0" bIns="0" rtlCol="0" anchor="ctr"/>
+          <a:lstStyle/>
+          <a:p>
+            <a:pPr marL="0" indent="0" algn="l">
               <a:buNone/>
             </a:pPr>
             <a:r>
@@ -2657,10 +2428,10 @@
           <a:ln/>
         </p:spPr>
         <p:txBody>
-          <a:bodyPr wrap="none" lIns="0" tIns="0" rIns="0" bIns="0" rtlCol="0" anchor="ctr" vert="horz"/>
-          <a:lstStyle/>
-          <a:p>
-            <a:pPr algn="l" indent="0" marL="0">
+          <a:bodyPr vert="horz" wrap="none" lIns="0" tIns="0" rIns="0" bIns="0" rtlCol="0" anchor="ctr"/>
+          <a:lstStyle/>
+          <a:p>
+            <a:pPr marL="0" indent="0" algn="l">
               <a:buNone/>
             </a:pPr>
             <a:r>
@@ -2696,10 +2467,10 @@
           <a:ln/>
         </p:spPr>
         <p:txBody>
-          <a:bodyPr wrap="none" lIns="0" tIns="0" rIns="0" bIns="0" rtlCol="0" anchor="ctr" vert="horz"/>
-          <a:lstStyle/>
-          <a:p>
-            <a:pPr algn="l" indent="0" marL="0">
+          <a:bodyPr vert="horz" wrap="none" lIns="0" tIns="0" rIns="0" bIns="0" rtlCol="0" anchor="ctr"/>
+          <a:lstStyle/>
+          <a:p>
+            <a:pPr marL="0" indent="0" algn="l">
               <a:buNone/>
             </a:pPr>
             <a:r>
@@ -2735,10 +2506,10 @@
           <a:ln/>
         </p:spPr>
         <p:txBody>
-          <a:bodyPr wrap="none" lIns="0" tIns="0" rIns="0" bIns="0" rtlCol="0" anchor="ctr" vert="horz"/>
-          <a:lstStyle/>
-          <a:p>
-            <a:pPr algn="l" indent="0" marL="0">
+          <a:bodyPr vert="horz" wrap="none" lIns="0" tIns="0" rIns="0" bIns="0" rtlCol="0" anchor="ctr"/>
+          <a:lstStyle/>
+          <a:p>
+            <a:pPr marL="0" indent="0" algn="l">
               <a:lnSpc>
                 <a:spcPts val="1440"/>
               </a:lnSpc>
@@ -2758,7 +2529,7 @@
             <a:endParaRPr lang="en-US" sz="1200" dirty="0"/>
           </a:p>
           <a:p>
-            <a:pPr algn="l" indent="0" marL="0">
+            <a:pPr marL="0" indent="0" algn="l">
               <a:lnSpc>
                 <a:spcPts val="1440"/>
               </a:lnSpc>
@@ -2797,10 +2568,10 @@
           <a:ln/>
         </p:spPr>
         <p:txBody>
-          <a:bodyPr wrap="none" lIns="0" tIns="0" rIns="0" bIns="0" rtlCol="0" anchor="ctr" vert="horz"/>
-          <a:lstStyle/>
-          <a:p>
-            <a:pPr algn="l" indent="0" marL="0">
+          <a:bodyPr vert="horz" wrap="none" lIns="0" tIns="0" rIns="0" bIns="0" rtlCol="0" anchor="ctr"/>
+          <a:lstStyle/>
+          <a:p>
+            <a:pPr marL="0" indent="0" algn="l">
               <a:buNone/>
             </a:pPr>
             <a:r>
@@ -2836,10 +2607,10 @@
           <a:ln/>
         </p:spPr>
         <p:txBody>
-          <a:bodyPr wrap="none" lIns="0" tIns="0" rIns="0" bIns="0" rtlCol="0" anchor="ctr" vert="horz"/>
-          <a:lstStyle/>
-          <a:p>
-            <a:pPr algn="l" indent="0" marL="0">
+          <a:bodyPr vert="horz" wrap="none" lIns="0" tIns="0" rIns="0" bIns="0" rtlCol="0" anchor="ctr"/>
+          <a:lstStyle/>
+          <a:p>
+            <a:pPr marL="0" indent="0" algn="l">
               <a:lnSpc>
                 <a:spcPts val="1440"/>
               </a:lnSpc>
@@ -2859,7 +2630,7 @@
             <a:endParaRPr lang="en-US" sz="1200" dirty="0"/>
           </a:p>
           <a:p>
-            <a:pPr algn="l" indent="0" marL="0">
+            <a:pPr marL="0" indent="0" algn="l">
               <a:lnSpc>
                 <a:spcPts val="1440"/>
               </a:lnSpc>
@@ -2898,10 +2669,10 @@
           <a:ln/>
         </p:spPr>
         <p:txBody>
-          <a:bodyPr wrap="none" lIns="0" tIns="0" rIns="0" bIns="0" rtlCol="0" anchor="ctr" vert="horz"/>
-          <a:lstStyle/>
-          <a:p>
-            <a:pPr algn="l" indent="0" marL="0">
+          <a:bodyPr vert="horz" wrap="none" lIns="0" tIns="0" rIns="0" bIns="0" rtlCol="0" anchor="ctr"/>
+          <a:lstStyle/>
+          <a:p>
+            <a:pPr marL="0" indent="0" algn="l">
               <a:buNone/>
             </a:pPr>
             <a:r>
@@ -2937,10 +2708,10 @@
           <a:ln/>
         </p:spPr>
         <p:txBody>
-          <a:bodyPr wrap="none" lIns="0" tIns="0" rIns="0" bIns="0" rtlCol="0" anchor="ctr" vert="horz"/>
-          <a:lstStyle/>
-          <a:p>
-            <a:pPr algn="l" indent="0" marL="0">
+          <a:bodyPr vert="horz" wrap="none" lIns="0" tIns="0" rIns="0" bIns="0" rtlCol="0" anchor="ctr"/>
+          <a:lstStyle/>
+          <a:p>
+            <a:pPr marL="0" indent="0" algn="l">
               <a:lnSpc>
                 <a:spcPts val="1440"/>
               </a:lnSpc>
@@ -2960,7 +2731,7 @@
             <a:endParaRPr lang="en-US" sz="1200" dirty="0"/>
           </a:p>
           <a:p>
-            <a:pPr algn="l" indent="0" marL="0">
+            <a:pPr marL="0" indent="0" algn="l">
               <a:lnSpc>
                 <a:spcPts val="1440"/>
               </a:lnSpc>
@@ -2999,10 +2770,10 @@
           <a:ln/>
         </p:spPr>
         <p:txBody>
-          <a:bodyPr wrap="none" lIns="0" tIns="0" rIns="0" bIns="0" rtlCol="0" anchor="ctr" vert="horz"/>
-          <a:lstStyle/>
-          <a:p>
-            <a:pPr algn="l" indent="0" marL="0">
+          <a:bodyPr vert="horz" wrap="none" lIns="0" tIns="0" rIns="0" bIns="0" rtlCol="0" anchor="ctr"/>
+          <a:lstStyle/>
+          <a:p>
+            <a:pPr marL="0" indent="0" algn="l">
               <a:buNone/>
             </a:pPr>
             <a:r>
@@ -3038,10 +2809,10 @@
           <a:ln/>
         </p:spPr>
         <p:txBody>
-          <a:bodyPr wrap="none" lIns="0" tIns="0" rIns="0" bIns="0" rtlCol="0" anchor="ctr" vert="horz"/>
-          <a:lstStyle/>
-          <a:p>
-            <a:pPr algn="l" indent="0" marL="0">
+          <a:bodyPr vert="horz" wrap="none" lIns="0" tIns="0" rIns="0" bIns="0" rtlCol="0" anchor="ctr"/>
+          <a:lstStyle/>
+          <a:p>
+            <a:pPr marL="0" indent="0" algn="l">
               <a:lnSpc>
                 <a:spcPts val="1440"/>
               </a:lnSpc>
@@ -3061,7 +2832,7 @@
             <a:endParaRPr lang="en-US" sz="1200" dirty="0"/>
           </a:p>
           <a:p>
-            <a:pPr algn="l" indent="0" marL="0">
+            <a:pPr marL="0" indent="0" algn="l">
               <a:lnSpc>
                 <a:spcPts val="1440"/>
               </a:lnSpc>
@@ -3100,10 +2871,10 @@
           <a:ln/>
         </p:spPr>
         <p:txBody>
-          <a:bodyPr wrap="none" lIns="0" tIns="0" rIns="0" bIns="0" rtlCol="0" anchor="ctr" vert="horz"/>
-          <a:lstStyle/>
-          <a:p>
-            <a:pPr algn="l" indent="0" marL="0">
+          <a:bodyPr vert="horz" wrap="none" lIns="0" tIns="0" rIns="0" bIns="0" rtlCol="0" anchor="ctr"/>
+          <a:lstStyle/>
+          <a:p>
+            <a:pPr marL="0" indent="0" algn="l">
               <a:buNone/>
             </a:pPr>
             <a:r>
@@ -3139,10 +2910,10 @@
           <a:ln/>
         </p:spPr>
         <p:txBody>
-          <a:bodyPr wrap="none" lIns="0" tIns="0" rIns="0" bIns="0" rtlCol="0" anchor="ctr" vert="horz"/>
-          <a:lstStyle/>
-          <a:p>
-            <a:pPr algn="l" indent="0" marL="0">
+          <a:bodyPr vert="horz" wrap="none" lIns="0" tIns="0" rIns="0" bIns="0" rtlCol="0" anchor="ctr"/>
+          <a:lstStyle/>
+          <a:p>
+            <a:pPr marL="0" indent="0" algn="l">
               <a:lnSpc>
                 <a:spcPts val="1440"/>
               </a:lnSpc>
@@ -3162,7 +2933,7 @@
             <a:endParaRPr lang="en-US" sz="1200" dirty="0"/>
           </a:p>
           <a:p>
-            <a:pPr algn="l" indent="0" marL="0">
+            <a:pPr marL="0" indent="0" algn="l">
               <a:lnSpc>
                 <a:spcPts val="1440"/>
               </a:lnSpc>
@@ -3201,10 +2972,10 @@
           <a:ln/>
         </p:spPr>
         <p:txBody>
-          <a:bodyPr wrap="none" lIns="0" tIns="0" rIns="0" bIns="0" rtlCol="0" anchor="ctr" vert="horz"/>
-          <a:lstStyle/>
-          <a:p>
-            <a:pPr algn="l" indent="0" marL="0">
+          <a:bodyPr vert="horz" wrap="none" lIns="0" tIns="0" rIns="0" bIns="0" rtlCol="0" anchor="ctr"/>
+          <a:lstStyle/>
+          <a:p>
+            <a:pPr marL="0" indent="0" algn="l">
               <a:buNone/>
             </a:pPr>
             <a:r>
@@ -3240,10 +3011,10 @@
           <a:ln/>
         </p:spPr>
         <p:txBody>
-          <a:bodyPr wrap="none" lIns="0" tIns="0" rIns="0" bIns="0" rtlCol="0" anchor="ctr" vert="horz"/>
-          <a:lstStyle/>
-          <a:p>
-            <a:pPr algn="l" indent="0" marL="0">
+          <a:bodyPr vert="horz" wrap="none" lIns="0" tIns="0" rIns="0" bIns="0" rtlCol="0" anchor="ctr"/>
+          <a:lstStyle/>
+          <a:p>
+            <a:pPr marL="0" indent="0" algn="l">
               <a:lnSpc>
                 <a:spcPts val="1440"/>
               </a:lnSpc>
@@ -3263,7 +3034,7 @@
             <a:endParaRPr lang="en-US" sz="1200" dirty="0"/>
           </a:p>
           <a:p>
-            <a:pPr algn="l" indent="0" marL="0">
+            <a:pPr marL="0" indent="0" algn="l">
               <a:lnSpc>
                 <a:spcPts val="1440"/>
               </a:lnSpc>
@@ -3302,10 +3073,10 @@
           <a:ln/>
         </p:spPr>
         <p:txBody>
-          <a:bodyPr wrap="none" lIns="0" tIns="0" rIns="0" bIns="0" rtlCol="0" anchor="ctr" vert="horz"/>
-          <a:lstStyle/>
-          <a:p>
-            <a:pPr algn="l" indent="0" marL="0">
+          <a:bodyPr vert="horz" wrap="none" lIns="0" tIns="0" rIns="0" bIns="0" rtlCol="0" anchor="ctr"/>
+          <a:lstStyle/>
+          <a:p>
+            <a:pPr marL="0" indent="0" algn="l">
               <a:buNone/>
             </a:pPr>
             <a:r>
@@ -3317,7 +3088,7 @@
                 <a:ea typeface="Montserrat" pitchFamily="34" charset="-122"/>
                 <a:cs typeface="Montserrat" pitchFamily="34" charset="-120"/>
               </a:rPr>
-              <a:t>Sistema diseñado para: subdirector, coordinador medular, coordinador transversal, líder de programa, instructor, con principios de gestión de datos y onboarding de usuario.</a:t>
+              <a:t>Sistema diseñado para los roles vigentes: Subdirector, Coordinación Académica, Asistente de Coordinación e Instructor, con acceso por rol y onboarding de usuarios.</a:t>
             </a:r>
             <a:endParaRPr lang="en-US" sz="900" dirty="0"/>
           </a:p>
@@ -3332,6 +3103,694 @@
 </file>
 
 <file path=ppt/slides/slide4.xml><?xml version="1.0" encoding="utf-8"?>
+<p:sld xmlns:a="http://schemas.openxmlformats.org/drawingml/2006/main" xmlns:r="http://schemas.openxmlformats.org/officeDocument/2006/relationships" xmlns:p="http://schemas.openxmlformats.org/presentationml/2006/main">
+  <p:cSld name="Slide 3">
+    <p:spTree>
+      <p:nvGrpSpPr>
+        <p:cNvPr id="1" name=""/>
+        <p:cNvGrpSpPr/>
+        <p:nvPr/>
+      </p:nvGrpSpPr>
+      <p:grpSpPr>
+        <a:xfrm>
+          <a:off x="0" y="0"/>
+          <a:ext cx="0" cy="0"/>
+          <a:chOff x="0" y="0"/>
+          <a:chExt cx="0" cy="0"/>
+        </a:xfrm>
+      </p:grpSpPr>
+      <p:pic>
+        <p:nvPicPr>
+          <p:cNvPr id="2" name="SK-3-img-1" descr="preencoded.png"/>
+          <p:cNvPicPr>
+            <a:picLocks noChangeAspect="1"/>
+          </p:cNvPicPr>
+          <p:nvPr/>
+        </p:nvPicPr>
+        <p:blipFill>
+          <a:blip r:embed="rId2"/>
+          <a:stretch>
+            <a:fillRect/>
+          </a:stretch>
+        </p:blipFill>
+        <p:spPr>
+          <a:xfrm>
+            <a:off x="0" y="0"/>
+            <a:ext cx="12192000" cy="6858000"/>
+          </a:xfrm>
+          <a:prstGeom prst="rect">
+            <a:avLst/>
+          </a:prstGeom>
+        </p:spPr>
+      </p:pic>
+      <p:pic>
+        <p:nvPicPr>
+          <p:cNvPr id="3" name="SK-3-img-2" descr="preencoded.png"/>
+          <p:cNvPicPr>
+            <a:picLocks noChangeAspect="1"/>
+          </p:cNvPicPr>
+          <p:nvPr/>
+        </p:nvPicPr>
+        <p:blipFill>
+          <a:blip r:embed="rId3"/>
+          <a:stretch>
+            <a:fillRect/>
+          </a:stretch>
+        </p:blipFill>
+        <p:spPr>
+          <a:xfrm>
+            <a:off x="548580" y="377130"/>
+            <a:ext cx="889992" cy="411361"/>
+          </a:xfrm>
+          <a:prstGeom prst="rect">
+            <a:avLst/>
+          </a:prstGeom>
+        </p:spPr>
+      </p:pic>
+      <p:pic>
+        <p:nvPicPr>
+          <p:cNvPr id="4" name="SK-3-img-3" descr="preencoded.png"/>
+          <p:cNvPicPr>
+            <a:picLocks noChangeAspect="1"/>
+          </p:cNvPicPr>
+          <p:nvPr/>
+        </p:nvPicPr>
+        <p:blipFill>
+          <a:blip r:embed="rId4"/>
+          <a:stretch>
+            <a:fillRect/>
+          </a:stretch>
+        </p:blipFill>
+        <p:spPr>
+          <a:xfrm>
+            <a:off x="548580" y="1961317"/>
+            <a:ext cx="2694384" cy="1803648"/>
+          </a:xfrm>
+          <a:prstGeom prst="rect">
+            <a:avLst/>
+          </a:prstGeom>
+        </p:spPr>
+      </p:pic>
+      <p:pic>
+        <p:nvPicPr>
+          <p:cNvPr id="5" name="SK-3-img-4" descr="preencoded.png"/>
+          <p:cNvPicPr>
+            <a:picLocks noChangeAspect="1"/>
+          </p:cNvPicPr>
+          <p:nvPr/>
+        </p:nvPicPr>
+        <p:blipFill>
+          <a:blip r:embed="rId5"/>
+          <a:stretch>
+            <a:fillRect/>
+          </a:stretch>
+        </p:blipFill>
+        <p:spPr>
+          <a:xfrm>
+            <a:off x="3401467" y="1947624"/>
+            <a:ext cx="2694384" cy="1782961"/>
+          </a:xfrm>
+          <a:prstGeom prst="rect">
+            <a:avLst/>
+          </a:prstGeom>
+        </p:spPr>
+      </p:pic>
+      <p:pic>
+        <p:nvPicPr>
+          <p:cNvPr id="6" name="SK-3-img-5" descr="preencoded.png"/>
+          <p:cNvPicPr>
+            <a:picLocks noChangeAspect="1"/>
+          </p:cNvPicPr>
+          <p:nvPr/>
+        </p:nvPicPr>
+        <p:blipFill>
+          <a:blip r:embed="rId6"/>
+          <a:stretch>
+            <a:fillRect/>
+          </a:stretch>
+        </p:blipFill>
+        <p:spPr>
+          <a:xfrm>
+            <a:off x="6254353" y="1947624"/>
+            <a:ext cx="2694384" cy="1782961"/>
+          </a:xfrm>
+          <a:prstGeom prst="rect">
+            <a:avLst/>
+          </a:prstGeom>
+        </p:spPr>
+      </p:pic>
+      <p:pic>
+        <p:nvPicPr>
+          <p:cNvPr id="16" name="SK-3-img-15" descr="preencoded.png"/>
+          <p:cNvPicPr>
+            <a:picLocks noChangeAspect="1"/>
+          </p:cNvPicPr>
+          <p:nvPr/>
+        </p:nvPicPr>
+        <p:blipFill>
+          <a:blip r:embed="rId7"/>
+          <a:stretch>
+            <a:fillRect/>
+          </a:stretch>
+        </p:blipFill>
+        <p:spPr>
+          <a:xfrm>
+            <a:off x="6888361" y="2125920"/>
+            <a:ext cx="743694" cy="452586"/>
+          </a:xfrm>
+          <a:prstGeom prst="rect">
+            <a:avLst/>
+          </a:prstGeom>
+        </p:spPr>
+      </p:pic>
+      <p:pic>
+        <p:nvPicPr>
+          <p:cNvPr id="17" name="SK-3-img-16" descr="preencoded.png"/>
+          <p:cNvPicPr>
+            <a:picLocks noChangeAspect="1"/>
+          </p:cNvPicPr>
+          <p:nvPr/>
+        </p:nvPicPr>
+        <p:blipFill>
+          <a:blip r:embed="rId8"/>
+          <a:stretch>
+            <a:fillRect/>
+          </a:stretch>
+        </p:blipFill>
+        <p:spPr>
+          <a:xfrm>
+            <a:off x="6473875" y="2125920"/>
+            <a:ext cx="365671" cy="445740"/>
+          </a:xfrm>
+          <a:prstGeom prst="rect">
+            <a:avLst/>
+          </a:prstGeom>
+        </p:spPr>
+      </p:pic>
+      <p:pic>
+        <p:nvPicPr>
+          <p:cNvPr id="18" name="SK-3-img-17" descr="preencoded.png"/>
+          <p:cNvPicPr>
+            <a:picLocks noChangeAspect="1"/>
+          </p:cNvPicPr>
+          <p:nvPr/>
+        </p:nvPicPr>
+        <p:blipFill>
+          <a:blip r:embed="rId9"/>
+          <a:stretch>
+            <a:fillRect/>
+          </a:stretch>
+        </p:blipFill>
+        <p:spPr>
+          <a:xfrm>
+            <a:off x="4120753" y="2112228"/>
+            <a:ext cx="621655" cy="479971"/>
+          </a:xfrm>
+          <a:prstGeom prst="rect">
+            <a:avLst/>
+          </a:prstGeom>
+        </p:spPr>
+      </p:pic>
+      <p:pic>
+        <p:nvPicPr>
+          <p:cNvPr id="19" name="SK-3-img-18" descr="preencoded.png"/>
+          <p:cNvPicPr>
+            <a:picLocks noChangeAspect="1"/>
+          </p:cNvPicPr>
+          <p:nvPr/>
+        </p:nvPicPr>
+        <p:blipFill>
+          <a:blip r:embed="rId10"/>
+          <a:stretch>
+            <a:fillRect/>
+          </a:stretch>
+        </p:blipFill>
+        <p:spPr>
+          <a:xfrm>
+            <a:off x="3572173" y="2125920"/>
+            <a:ext cx="511969" cy="432048"/>
+          </a:xfrm>
+          <a:prstGeom prst="rect">
+            <a:avLst/>
+          </a:prstGeom>
+        </p:spPr>
+      </p:pic>
+      <p:pic>
+        <p:nvPicPr>
+          <p:cNvPr id="20" name="SK-3-img-19" descr="preencoded.png"/>
+          <p:cNvPicPr>
+            <a:picLocks noChangeAspect="1"/>
+          </p:cNvPicPr>
+          <p:nvPr/>
+        </p:nvPicPr>
+        <p:blipFill>
+          <a:blip r:embed="rId11"/>
+          <a:stretch>
+            <a:fillRect/>
+          </a:stretch>
+        </p:blipFill>
+        <p:spPr>
+          <a:xfrm>
+            <a:off x="719286" y="2160151"/>
+            <a:ext cx="463153" cy="377130"/>
+          </a:xfrm>
+          <a:prstGeom prst="rect">
+            <a:avLst/>
+          </a:prstGeom>
+        </p:spPr>
+      </p:pic>
+      <p:sp>
+        <p:nvSpPr>
+          <p:cNvPr id="21" name="SK-3-text-20"/>
+          <p:cNvSpPr/>
+          <p:nvPr/>
+        </p:nvSpPr>
+        <p:spPr>
+          <a:xfrm>
+            <a:off x="696069" y="473125"/>
+            <a:ext cx="765721" cy="212527"/>
+          </a:xfrm>
+          <a:prstGeom prst="rect">
+            <a:avLst/>
+          </a:prstGeom>
+          <a:noFill/>
+          <a:ln/>
+        </p:spPr>
+        <p:txBody>
+          <a:bodyPr vert="horz" wrap="none" lIns="0" tIns="0" rIns="0" bIns="0" rtlCol="0" anchor="ctr"/>
+          <a:lstStyle/>
+          <a:p>
+            <a:pPr marL="0" indent="0" algn="ctr">
+              <a:buNone/>
+            </a:pPr>
+            <a:r>
+              <a:rPr lang="en-US" sz="1500" b="1" dirty="0">
+                <a:solidFill>
+                  <a:srgbClr val="FFFFFF"/>
+                </a:solidFill>
+                <a:latin typeface="Montserrat" pitchFamily="34" charset="0"/>
+                <a:ea typeface="Montserrat" pitchFamily="34" charset="-122"/>
+                <a:cs typeface="Montserrat" pitchFamily="34" charset="-120"/>
+              </a:rPr>
+              <a:t>SENA</a:t>
+            </a:r>
+            <a:endParaRPr lang="en-US" sz="1500" dirty="0"/>
+          </a:p>
+        </p:txBody>
+      </p:sp>
+      <p:sp>
+        <p:nvSpPr>
+          <p:cNvPr id="22" name="SK-3-text-21"/>
+          <p:cNvSpPr/>
+          <p:nvPr/>
+        </p:nvSpPr>
+        <p:spPr>
+          <a:xfrm>
+            <a:off x="1743373" y="411361"/>
+            <a:ext cx="8812530" cy="425053"/>
+          </a:xfrm>
+          <a:prstGeom prst="rect">
+            <a:avLst/>
+          </a:prstGeom>
+          <a:noFill/>
+          <a:ln/>
+        </p:spPr>
+        <p:txBody>
+          <a:bodyPr vert="horz" wrap="none" lIns="0" tIns="0" rIns="0" bIns="0" rtlCol="0" anchor="ctr"/>
+          <a:lstStyle/>
+          <a:p>
+            <a:pPr marL="0" indent="0" algn="l">
+              <a:buNone/>
+            </a:pPr>
+            <a:r>
+              <a:rPr lang="en-US" sz="2700" b="1" dirty="0">
+                <a:solidFill>
+                  <a:srgbClr val="000000"/>
+                </a:solidFill>
+              </a:rPr>
+              <a:t>¿Cómo funciona en la práctica?</a:t>
+            </a:r>
+            <a:endParaRPr lang="en-US" sz="2700" dirty="0"/>
+          </a:p>
+        </p:txBody>
+      </p:sp>
+      <p:sp>
+        <p:nvSpPr>
+          <p:cNvPr id="23" name="SK-3-text-22"/>
+          <p:cNvSpPr/>
+          <p:nvPr/>
+        </p:nvSpPr>
+        <p:spPr>
+          <a:xfrm>
+            <a:off x="1743373" y="877788"/>
+            <a:ext cx="10448627" cy="294829"/>
+          </a:xfrm>
+          <a:prstGeom prst="rect">
+            <a:avLst/>
+          </a:prstGeom>
+          <a:noFill/>
+          <a:ln/>
+        </p:spPr>
+        <p:txBody>
+          <a:bodyPr vert="horz" wrap="none" lIns="0" tIns="0" rIns="0" bIns="0" rtlCol="0" anchor="ctr"/>
+          <a:lstStyle/>
+          <a:p>
+            <a:pPr marL="0" indent="0" algn="l">
+              <a:buNone/>
+            </a:pPr>
+            <a:r>
+              <a:rPr lang="en-US" sz="1500" dirty="0">
+                <a:solidFill>
+                  <a:srgbClr val="333333"/>
+                </a:solidFill>
+                <a:latin typeface="Montserrat" pitchFamily="34" charset="0"/>
+                <a:ea typeface="Montserrat" pitchFamily="34" charset="-122"/>
+                <a:cs typeface="Montserrat" pitchFamily="34" charset="-120"/>
+              </a:rPr>
+              <a:t>Del Excel del líder al horario, sin rehacer nada a mano</a:t>
+            </a:r>
+            <a:endParaRPr lang="en-US" sz="1500" dirty="0"/>
+          </a:p>
+        </p:txBody>
+      </p:sp>
+      <p:sp>
+        <p:nvSpPr>
+          <p:cNvPr id="24" name="SK-3-text-23"/>
+          <p:cNvSpPr/>
+          <p:nvPr/>
+        </p:nvSpPr>
+        <p:spPr>
+          <a:xfrm>
+            <a:off x="707082" y="2763649"/>
+            <a:ext cx="3752850" cy="267444"/>
+          </a:xfrm>
+          <a:prstGeom prst="rect">
+            <a:avLst/>
+          </a:prstGeom>
+          <a:noFill/>
+          <a:ln/>
+        </p:spPr>
+        <p:txBody>
+          <a:bodyPr vert="horz" wrap="none" lIns="0" tIns="0" rIns="0" bIns="0" rtlCol="0" anchor="ctr"/>
+          <a:lstStyle/>
+          <a:p>
+            <a:pPr marL="0" indent="0" algn="l">
+              <a:buNone/>
+            </a:pPr>
+            <a:r>
+              <a:rPr lang="en-US" sz="1500" b="1" dirty="0">
+                <a:solidFill>
+                  <a:srgbClr val="000000"/>
+                </a:solidFill>
+                <a:latin typeface="Montserrat" pitchFamily="34" charset="0"/>
+                <a:ea typeface="Montserrat" pitchFamily="34" charset="-122"/>
+                <a:cs typeface="Montserrat" pitchFamily="34" charset="-120"/>
+              </a:rPr>
+              <a:t>1 · Llega el Excel</a:t>
+            </a:r>
+            <a:endParaRPr lang="en-US" sz="1500" dirty="0"/>
+          </a:p>
+        </p:txBody>
+      </p:sp>
+      <p:sp>
+        <p:nvSpPr>
+          <p:cNvPr id="25" name="SK-3-text-24"/>
+          <p:cNvSpPr/>
+          <p:nvPr/>
+        </p:nvSpPr>
+        <p:spPr>
+          <a:xfrm>
+            <a:off x="707082" y="3113395"/>
+            <a:ext cx="2023765" cy="452586"/>
+          </a:xfrm>
+          <a:prstGeom prst="rect">
+            <a:avLst/>
+          </a:prstGeom>
+          <a:noFill/>
+          <a:ln/>
+        </p:spPr>
+        <p:txBody>
+          <a:bodyPr vert="horz" wrap="square" lIns="0" tIns="0" rIns="0" bIns="0" rtlCol="0" anchor="ctr"/>
+          <a:lstStyle/>
+          <a:p>
+            <a:pPr marL="0" indent="0" algn="l">
+              <a:lnSpc>
+                <a:spcPts val="1440"/>
+              </a:lnSpc>
+              <a:buNone/>
+            </a:pPr>
+            <a:r>
+              <a:rPr lang="en-US" sz="1200" dirty="0">
+                <a:solidFill>
+                  <a:srgbClr val="333333"/>
+                </a:solidFill>
+                <a:latin typeface="Montserrat" pitchFamily="34" charset="0"/>
+                <a:ea typeface="Montserrat" pitchFamily="34" charset="-122"/>
+                <a:cs typeface="Montserrat" pitchFamily="34" charset="-120"/>
+              </a:rPr>
+              <a:t>Se carga tal cual lo envía el líder.</a:t>
+            </a:r>
+            <a:endParaRPr lang="en-US" sz="1200" dirty="0"/>
+          </a:p>
+          <a:p>
+            <a:pPr marL="0" indent="0" algn="l">
+              <a:lnSpc>
+                <a:spcPts val="1440"/>
+              </a:lnSpc>
+              <a:buNone/>
+            </a:pPr>
+            <a:endParaRPr lang="en-US" sz="1200" dirty="0"/>
+          </a:p>
+        </p:txBody>
+      </p:sp>
+      <p:sp>
+        <p:nvSpPr>
+          <p:cNvPr id="26" name="SK-3-text-25"/>
+          <p:cNvSpPr/>
+          <p:nvPr/>
+        </p:nvSpPr>
+        <p:spPr>
+          <a:xfrm>
+            <a:off x="3572173" y="2777490"/>
+            <a:ext cx="2838450" cy="226219"/>
+          </a:xfrm>
+          <a:prstGeom prst="rect">
+            <a:avLst/>
+          </a:prstGeom>
+          <a:noFill/>
+          <a:ln/>
+        </p:spPr>
+        <p:txBody>
+          <a:bodyPr vert="horz" wrap="none" lIns="0" tIns="0" rIns="0" bIns="0" rtlCol="0" anchor="ctr"/>
+          <a:lstStyle/>
+          <a:p>
+            <a:pPr marL="0" indent="0" algn="l">
+              <a:buNone/>
+            </a:pPr>
+            <a:r>
+              <a:rPr lang="en-US" sz="1500" b="1" dirty="0">
+                <a:solidFill>
+                  <a:srgbClr val="000000"/>
+                </a:solidFill>
+                <a:latin typeface="Montserrat" pitchFamily="34" charset="0"/>
+                <a:ea typeface="Montserrat" pitchFamily="34" charset="-122"/>
+                <a:cs typeface="Montserrat" pitchFamily="34" charset="-120"/>
+              </a:rPr>
+              <a:t>2 · El sistema revisa</a:t>
+            </a:r>
+            <a:endParaRPr lang="en-US" sz="1500" dirty="0"/>
+          </a:p>
+        </p:txBody>
+      </p:sp>
+      <p:sp>
+        <p:nvSpPr>
+          <p:cNvPr id="27" name="SK-3-text-26"/>
+          <p:cNvSpPr/>
+          <p:nvPr/>
+        </p:nvSpPr>
+        <p:spPr>
+          <a:xfrm>
+            <a:off x="3559969" y="3113395"/>
+            <a:ext cx="2194471" cy="452586"/>
+          </a:xfrm>
+          <a:prstGeom prst="rect">
+            <a:avLst/>
+          </a:prstGeom>
+          <a:noFill/>
+          <a:ln/>
+        </p:spPr>
+        <p:txBody>
+          <a:bodyPr vert="horz" wrap="square" lIns="0" tIns="0" rIns="0" bIns="0" rtlCol="0" anchor="ctr"/>
+          <a:lstStyle/>
+          <a:p>
+            <a:pPr marL="0" indent="0" algn="l">
+              <a:lnSpc>
+                <a:spcPts val="1440"/>
+              </a:lnSpc>
+              <a:buNone/>
+            </a:pPr>
+            <a:r>
+              <a:rPr lang="en-US" sz="1200" dirty="0">
+                <a:solidFill>
+                  <a:srgbClr val="333333"/>
+                </a:solidFill>
+                <a:latin typeface="Montserrat" pitchFamily="34" charset="0"/>
+                <a:ea typeface="Montserrat" pitchFamily="34" charset="-122"/>
+                <a:cs typeface="Montserrat" pitchFamily="34" charset="-120"/>
+              </a:rPr>
+              <a:t>Ordena y valida antes de guardar.</a:t>
+            </a:r>
+            <a:endParaRPr lang="en-US" sz="1200" dirty="0"/>
+          </a:p>
+          <a:p>
+            <a:pPr marL="0" indent="0" algn="l">
+              <a:lnSpc>
+                <a:spcPts val="1440"/>
+              </a:lnSpc>
+              <a:buNone/>
+            </a:pPr>
+            <a:endParaRPr lang="en-US" sz="1200" dirty="0"/>
+          </a:p>
+        </p:txBody>
+      </p:sp>
+      <p:sp>
+        <p:nvSpPr>
+          <p:cNvPr id="28" name="SK-3-text-27"/>
+          <p:cNvSpPr/>
+          <p:nvPr/>
+        </p:nvSpPr>
+        <p:spPr>
+          <a:xfrm>
+            <a:off x="6425059" y="2770495"/>
+            <a:ext cx="4210050" cy="260598"/>
+          </a:xfrm>
+          <a:prstGeom prst="rect">
+            <a:avLst/>
+          </a:prstGeom>
+          <a:noFill/>
+          <a:ln/>
+        </p:spPr>
+        <p:txBody>
+          <a:bodyPr vert="horz" wrap="none" lIns="0" tIns="0" rIns="0" bIns="0" rtlCol="0" anchor="ctr"/>
+          <a:lstStyle/>
+          <a:p>
+            <a:pPr marL="0" indent="0" algn="l">
+              <a:buNone/>
+            </a:pPr>
+            <a:r>
+              <a:rPr lang="en-US" sz="1500" b="1" dirty="0">
+                <a:solidFill>
+                  <a:srgbClr val="000000"/>
+                </a:solidFill>
+                <a:latin typeface="Montserrat" pitchFamily="34" charset="0"/>
+                <a:ea typeface="Montserrat" pitchFamily="34" charset="-122"/>
+                <a:cs typeface="Montserrat" pitchFamily="34" charset="-120"/>
+              </a:rPr>
+              <a:t>3 · Alertas automáticas</a:t>
+            </a:r>
+            <a:endParaRPr lang="en-US" sz="1500" dirty="0"/>
+          </a:p>
+        </p:txBody>
+      </p:sp>
+      <p:sp>
+        <p:nvSpPr>
+          <p:cNvPr id="29" name="SK-3-text-28"/>
+          <p:cNvSpPr/>
+          <p:nvPr/>
+        </p:nvSpPr>
+        <p:spPr>
+          <a:xfrm>
+            <a:off x="6412855" y="3113395"/>
+            <a:ext cx="2450455" cy="438894"/>
+          </a:xfrm>
+          <a:prstGeom prst="rect">
+            <a:avLst/>
+          </a:prstGeom>
+          <a:noFill/>
+          <a:ln/>
+        </p:spPr>
+        <p:txBody>
+          <a:bodyPr vert="horz" wrap="square" lIns="0" tIns="0" rIns="0" bIns="0" rtlCol="0" anchor="ctr"/>
+          <a:lstStyle/>
+          <a:p>
+            <a:pPr marL="0" indent="0" algn="l">
+              <a:lnSpc>
+                <a:spcPts val="1440"/>
+              </a:lnSpc>
+              <a:buNone/>
+            </a:pPr>
+            <a:r>
+              <a:rPr lang="en-US" sz="1200" dirty="0">
+                <a:solidFill>
+                  <a:srgbClr val="333333"/>
+                </a:solidFill>
+                <a:latin typeface="Montserrat" pitchFamily="34" charset="0"/>
+                <a:ea typeface="Montserrat" pitchFamily="34" charset="-122"/>
+                <a:cs typeface="Montserrat" pitchFamily="34" charset="-120"/>
+              </a:rPr>
+              <a:t>Avisa cruces, sobrecargas y faltantes.</a:t>
+            </a:r>
+            <a:endParaRPr lang="en-US" sz="1200" dirty="0"/>
+          </a:p>
+          <a:p>
+            <a:pPr marL="0" indent="0" algn="l">
+              <a:lnSpc>
+                <a:spcPts val="1440"/>
+              </a:lnSpc>
+              <a:buNone/>
+            </a:pPr>
+            <a:endParaRPr lang="en-US" sz="1200" dirty="0"/>
+          </a:p>
+        </p:txBody>
+      </p:sp>
+      <p:sp>
+        <p:nvSpPr>
+          <p:cNvPr id="36" name="SK-3-text-35"/>
+          <p:cNvSpPr/>
+          <p:nvPr/>
+        </p:nvSpPr>
+        <p:spPr>
+          <a:xfrm>
+            <a:off x="511969" y="4937760"/>
+            <a:ext cx="11680031" cy="178296"/>
+          </a:xfrm>
+          <a:prstGeom prst="rect">
+            <a:avLst/>
+          </a:prstGeom>
+          <a:noFill/>
+          <a:ln/>
+        </p:spPr>
+        <p:txBody>
+          <a:bodyPr vert="horz" wrap="none" lIns="0" tIns="0" rIns="0" bIns="0" rtlCol="0" anchor="ctr"/>
+          <a:lstStyle/>
+          <a:p>
+            <a:pPr marL="0" indent="0" algn="l">
+              <a:buNone/>
+            </a:pPr>
+            <a:r>
+              <a:rPr lang="en-US" sz="900" dirty="0">
+                <a:solidFill>
+                  <a:srgbClr val="333333"/>
+                </a:solidFill>
+                <a:latin typeface="Montserrat" pitchFamily="34" charset="0"/>
+                <a:ea typeface="Montserrat" pitchFamily="34" charset="-122"/>
+                <a:cs typeface="Montserrat" pitchFamily="34" charset="-120"/>
+              </a:rPr>
+              <a:t>Cargar la planeación deja de ser retranscribir horarios a mano: el sistema los organiza y valida.</a:t>
+            </a:r>
+            <a:endParaRPr lang="en-US" sz="900" dirty="0"/>
+          </a:p>
+        </p:txBody>
+      </p:sp>
+    </p:spTree>
+  </p:cSld>
+  <p:clrMapOvr>
+    <a:masterClrMapping/>
+  </p:clrMapOvr>
+</p:sld>
+</file>
+
+<file path=ppt/slides/slide5.xml><?xml version="1.0" encoding="utf-8"?>
 <p:sld xmlns:a="http://schemas.openxmlformats.org/drawingml/2006/main" xmlns:r="http://schemas.openxmlformats.org/officeDocument/2006/relationships" xmlns:p="http://schemas.openxmlformats.org/presentationml/2006/main">
   <p:cSld name="Slide 4">
     <p:spTree>
@@ -3350,55 +3809,7 @@
       </p:grpSpPr>
       <p:pic>
         <p:nvPicPr>
-          <p:cNvPr id="2" name="SK-4-img-1" descr="preencoded.png">    </p:cNvPr>
-          <p:cNvPicPr>
-            <a:picLocks noChangeAspect="1"/>
-          </p:cNvPicPr>
-          <p:nvPr/>
-        </p:nvPicPr>
-        <p:blipFill>
-          <a:blip r:embed="rId1"/>
-          <a:stretch>
-            <a:fillRect/>
-          </a:stretch>
-        </p:blipFill>
-        <p:spPr>
-          <a:xfrm>
-            <a:off x="0" y="0"/>
-            <a:ext cx="12192000" cy="6858000"/>
-          </a:xfrm>
-          <a:prstGeom prst="rect">
-            <a:avLst/>
-          </a:prstGeom>
-        </p:spPr>
-      </p:pic>
-      <p:pic>
-        <p:nvPicPr>
-          <p:cNvPr id="3" name="SK-4-img-2" descr="preencoded.png">    </p:cNvPr>
-          <p:cNvPicPr>
-            <a:picLocks noChangeAspect="1"/>
-          </p:cNvPicPr>
-          <p:nvPr/>
-        </p:nvPicPr>
-        <p:blipFill>
-          <a:blip r:embed="rId2"/>
-          <a:stretch>
-            <a:fillRect/>
-          </a:stretch>
-        </p:blipFill>
-        <p:spPr>
-          <a:xfrm>
-            <a:off x="560784" y="424458"/>
-            <a:ext cx="1011882" cy="405854"/>
-          </a:xfrm>
-          <a:prstGeom prst="rect">
-            <a:avLst/>
-          </a:prstGeom>
-        </p:spPr>
-      </p:pic>
-      <p:pic>
-        <p:nvPicPr>
-          <p:cNvPr id="4" name="SK-4-img-3" descr="preencoded.png">    </p:cNvPr>
+          <p:cNvPr id="2" name="SK-4-img-1" descr="preencoded.png"/>
           <p:cNvPicPr>
             <a:picLocks noChangeAspect="1"/>
           </p:cNvPicPr>
@@ -3412,8 +3823,8 @@
         </p:blipFill>
         <p:spPr>
           <a:xfrm>
-            <a:off x="621655" y="3699867"/>
-            <a:ext cx="10936188" cy="973782"/>
+            <a:off x="0" y="0"/>
+            <a:ext cx="12192000" cy="6858000"/>
           </a:xfrm>
           <a:prstGeom prst="rect">
             <a:avLst/>
@@ -3422,7 +3833,7 @@
       </p:pic>
       <p:pic>
         <p:nvPicPr>
-          <p:cNvPr id="5" name="SK-4-img-4" descr="preencoded.png">    </p:cNvPr>
+          <p:cNvPr id="3" name="SK-4-img-2" descr="preencoded.png"/>
           <p:cNvPicPr>
             <a:picLocks noChangeAspect="1"/>
           </p:cNvPicPr>
@@ -3436,8 +3847,8 @@
         </p:blipFill>
         <p:spPr>
           <a:xfrm>
-            <a:off x="877788" y="4930825"/>
-            <a:ext cx="451098" cy="329059"/>
+            <a:off x="560784" y="424458"/>
+            <a:ext cx="1011882" cy="405854"/>
           </a:xfrm>
           <a:prstGeom prst="rect">
             <a:avLst/>
@@ -3446,7 +3857,7 @@
       </p:pic>
       <p:pic>
         <p:nvPicPr>
-          <p:cNvPr id="6" name="SK-4-img-5" descr="preencoded.png">    </p:cNvPr>
+          <p:cNvPr id="4" name="SK-4-img-3" descr="preencoded.png"/>
           <p:cNvPicPr>
             <a:picLocks noChangeAspect="1"/>
           </p:cNvPicPr>
@@ -3460,6 +3871,54 @@
         </p:blipFill>
         <p:spPr>
           <a:xfrm>
+            <a:off x="621655" y="3699867"/>
+            <a:ext cx="10936188" cy="973782"/>
+          </a:xfrm>
+          <a:prstGeom prst="rect">
+            <a:avLst/>
+          </a:prstGeom>
+        </p:spPr>
+      </p:pic>
+      <p:pic>
+        <p:nvPicPr>
+          <p:cNvPr id="5" name="SK-4-img-4" descr="preencoded.png"/>
+          <p:cNvPicPr>
+            <a:picLocks noChangeAspect="1"/>
+          </p:cNvPicPr>
+          <p:nvPr/>
+        </p:nvPicPr>
+        <p:blipFill>
+          <a:blip r:embed="rId6"/>
+          <a:stretch>
+            <a:fillRect/>
+          </a:stretch>
+        </p:blipFill>
+        <p:spPr>
+          <a:xfrm>
+            <a:off x="877788" y="4930825"/>
+            <a:ext cx="451098" cy="329059"/>
+          </a:xfrm>
+          <a:prstGeom prst="rect">
+            <a:avLst/>
+          </a:prstGeom>
+        </p:spPr>
+      </p:pic>
+      <p:pic>
+        <p:nvPicPr>
+          <p:cNvPr id="6" name="SK-4-img-5" descr="preencoded.png"/>
+          <p:cNvPicPr>
+            <a:picLocks noChangeAspect="1"/>
+          </p:cNvPicPr>
+          <p:nvPr/>
+        </p:nvPicPr>
+        <p:blipFill>
+          <a:blip r:embed="rId7"/>
+          <a:stretch>
+            <a:fillRect/>
+          </a:stretch>
+        </p:blipFill>
+        <p:spPr>
+          <a:xfrm>
             <a:off x="438894" y="1220688"/>
             <a:ext cx="10692259" cy="2091630"/>
           </a:xfrm>
@@ -3486,10 +3945,10 @@
           <a:ln/>
         </p:spPr>
         <p:txBody>
-          <a:bodyPr wrap="none" lIns="0" tIns="0" rIns="0" bIns="0" rtlCol="0" anchor="ctr" vert="horz"/>
-          <a:lstStyle/>
-          <a:p>
-            <a:pPr algn="ctr" indent="0" marL="0">
+          <a:bodyPr vert="horz" wrap="none" lIns="0" tIns="0" rIns="0" bIns="0" rtlCol="0" anchor="ctr"/>
+          <a:lstStyle/>
+          <a:p>
+            <a:pPr marL="0" indent="0" algn="ctr">
               <a:buNone/>
             </a:pPr>
             <a:r>
@@ -3525,10 +3984,10 @@
           <a:ln/>
         </p:spPr>
         <p:txBody>
-          <a:bodyPr wrap="none" lIns="0" tIns="0" rIns="0" bIns="0" rtlCol="0" anchor="ctr" vert="horz"/>
-          <a:lstStyle/>
-          <a:p>
-            <a:pPr algn="l" indent="0" marL="0">
+          <a:bodyPr vert="horz" wrap="none" lIns="0" tIns="0" rIns="0" bIns="0" rtlCol="0" anchor="ctr"/>
+          <a:lstStyle/>
+          <a:p>
+            <a:pPr marL="0" indent="0" algn="l">
               <a:buNone/>
             </a:pPr>
             <a:r>
@@ -3551,7 +4010,7 @@
         </p:nvSpPr>
         <p:spPr>
           <a:xfrm>
-            <a:off x="865584" y="3874740"/>
+            <a:off x="1225227" y="4023719"/>
             <a:ext cx="9119592" cy="624036"/>
           </a:xfrm>
           <a:prstGeom prst="rect">
@@ -3561,10 +4020,10 @@
           <a:ln/>
         </p:spPr>
         <p:txBody>
-          <a:bodyPr wrap="none" lIns="0" tIns="0" rIns="0" bIns="0" rtlCol="0" anchor="ctr" vert="horz"/>
-          <a:lstStyle/>
-          <a:p>
-            <a:pPr algn="l" indent="0" marL="0">
+          <a:bodyPr vert="horz" wrap="square" lIns="0" tIns="0" rIns="0" bIns="0" rtlCol="0" anchor="ctr"/>
+          <a:lstStyle/>
+          <a:p>
+            <a:pPr marL="0" indent="0" algn="l">
               <a:lnSpc>
                 <a:spcPts val="2535"/>
               </a:lnSpc>
@@ -3579,19 +4038,47 @@
                 <a:ea typeface="Roboto" pitchFamily="34" charset="-122"/>
                 <a:cs typeface="Roboto" pitchFamily="34" charset="-120"/>
               </a:rPr>
-              <a:t>Hoy el proyecto se encuentra en construcción, integrando las partes del sistema y</a:t>
+              <a:t>Hoy el sistema está integrado y entrando a la etapa de pruebas con datos reales del programa ADSO, antes del despliegue.</a:t>
             </a:r>
             <a:endParaRPr lang="en-US" sz="1950" dirty="0"/>
           </a:p>
           <a:p>
-            <a:pPr algn="l" indent="0" marL="0">
+            <a:pPr marL="0" indent="0" algn="l">
               <a:lnSpc>
                 <a:spcPts val="2535"/>
               </a:lnSpc>
               <a:buNone/>
             </a:pPr>
-            <a:r>
-              <a:rPr lang="en-US" sz="1950" dirty="0">
+            <a:endParaRPr lang="en-US" sz="1950" dirty="0"/>
+          </a:p>
+        </p:txBody>
+      </p:sp>
+      <p:sp>
+        <p:nvSpPr>
+          <p:cNvPr id="10" name="SK-4-text-9"/>
+          <p:cNvSpPr/>
+          <p:nvPr/>
+        </p:nvSpPr>
+        <p:spPr>
+          <a:xfrm>
+            <a:off x="1377553" y="4999434"/>
+            <a:ext cx="5888355" cy="260598"/>
+          </a:xfrm>
+          <a:prstGeom prst="rect">
+            <a:avLst/>
+          </a:prstGeom>
+          <a:noFill/>
+          <a:ln/>
+        </p:spPr>
+        <p:txBody>
+          <a:bodyPr vert="horz" wrap="none" lIns="0" tIns="0" rIns="0" bIns="0" rtlCol="0" anchor="ctr"/>
+          <a:lstStyle/>
+          <a:p>
+            <a:pPr marL="0" indent="0" algn="l">
+              <a:buNone/>
+            </a:pPr>
+            <a:r>
+              <a:rPr lang="en-US" sz="1650" dirty="0">
                 <a:solidFill>
                   <a:srgbClr val="000000"/>
                 </a:solidFill>
@@ -3599,38 +4086,40 @@
                 <a:ea typeface="Roboto" pitchFamily="34" charset="-122"/>
                 <a:cs typeface="Roboto" pitchFamily="34" charset="-120"/>
               </a:rPr>
-              <a:t>preparando la etapa de pruebas.</a:t>
-            </a:r>
-            <a:endParaRPr lang="en-US" sz="1950" dirty="0"/>
-          </a:p>
-        </p:txBody>
-      </p:sp>
-      <p:sp>
-        <p:nvSpPr>
-          <p:cNvPr id="10" name="SK-4-text-9"/>
-          <p:cNvSpPr/>
-          <p:nvPr/>
-        </p:nvSpPr>
-        <p:spPr>
-          <a:xfrm>
-            <a:off x="1377553" y="4999434"/>
-            <a:ext cx="5888355" cy="260598"/>
-          </a:xfrm>
-          <a:prstGeom prst="rect">
-            <a:avLst/>
-          </a:prstGeom>
-          <a:noFill/>
-          <a:ln/>
-        </p:spPr>
-        <p:txBody>
-          <a:bodyPr wrap="none" lIns="0" tIns="0" rIns="0" bIns="0" rtlCol="0" anchor="ctr" vert="horz"/>
-          <a:lstStyle/>
-          <a:p>
-            <a:pPr algn="l" indent="0" marL="0">
-              <a:buNone/>
-            </a:pPr>
-            <a:r>
-              <a:rPr lang="en-US" sz="1650" dirty="0">
+              <a:t>Equipo y acompañamiento</a:t>
+            </a:r>
+            <a:endParaRPr lang="en-US" sz="1650" dirty="0"/>
+          </a:p>
+        </p:txBody>
+      </p:sp>
+      <p:sp>
+        <p:nvSpPr>
+          <p:cNvPr id="11" name="SK-4-text-10"/>
+          <p:cNvSpPr/>
+          <p:nvPr/>
+        </p:nvSpPr>
+        <p:spPr>
+          <a:xfrm>
+            <a:off x="877788" y="5542954"/>
+            <a:ext cx="3669655" cy="445740"/>
+          </a:xfrm>
+          <a:prstGeom prst="rect">
+            <a:avLst/>
+          </a:prstGeom>
+          <a:noFill/>
+          <a:ln/>
+        </p:spPr>
+        <p:txBody>
+          <a:bodyPr vert="horz" wrap="none" lIns="0" tIns="0" rIns="0" bIns="0" rtlCol="0" anchor="ctr"/>
+          <a:lstStyle/>
+          <a:p>
+            <a:pPr>
+              <a:lnSpc>
+                <a:spcPts val="1800"/>
+              </a:lnSpc>
+            </a:pPr>
+            <a:r>
+              <a:rPr lang="en-US" sz="1500" dirty="0">
                 <a:solidFill>
                   <a:srgbClr val="000000"/>
                 </a:solidFill>
@@ -3638,38 +4127,14 @@
                 <a:ea typeface="Roboto" pitchFamily="34" charset="-122"/>
                 <a:cs typeface="Roboto" pitchFamily="34" charset="-120"/>
               </a:rPr>
-              <a:t>Equipo y acompañamiento</a:t>
-            </a:r>
-            <a:endParaRPr lang="en-US" sz="1650" dirty="0"/>
-          </a:p>
-        </p:txBody>
-      </p:sp>
-      <p:sp>
-        <p:nvSpPr>
-          <p:cNvPr id="11" name="SK-4-text-10"/>
-          <p:cNvSpPr/>
-          <p:nvPr/>
-        </p:nvSpPr>
-        <p:spPr>
-          <a:xfrm>
-            <a:off x="865584" y="5479405"/>
-            <a:ext cx="3669655" cy="445740"/>
-          </a:xfrm>
-          <a:prstGeom prst="rect">
-            <a:avLst/>
-          </a:prstGeom>
-          <a:noFill/>
-          <a:ln/>
-        </p:spPr>
-        <p:txBody>
-          <a:bodyPr wrap="none" lIns="0" tIns="0" rIns="0" bIns="0" rtlCol="0" anchor="ctr" vert="horz"/>
-          <a:lstStyle/>
-          <a:p>
-            <a:pPr algn="l" indent="0" marL="0">
+              <a:t>Aprendices: </a:t>
+            </a:r>
+          </a:p>
+          <a:p>
+            <a:pPr>
               <a:lnSpc>
                 <a:spcPts val="1800"/>
               </a:lnSpc>
-              <a:buNone/>
             </a:pPr>
             <a:r>
               <a:rPr lang="en-US" sz="1500" dirty="0">
@@ -3680,12 +4145,12 @@
                 <a:ea typeface="Roboto" pitchFamily="34" charset="-122"/>
                 <a:cs typeface="Roboto" pitchFamily="34" charset="-120"/>
               </a:rPr>
-              <a:t>Aprendices: Jair Enrique González Buelvas y</a:t>
+              <a:t>Laura Sofía Posada</a:t>
             </a:r>
             <a:endParaRPr lang="en-US" sz="1500" dirty="0"/>
           </a:p>
           <a:p>
-            <a:pPr algn="l" indent="0" marL="0">
+            <a:pPr marL="0" indent="0" algn="l">
               <a:lnSpc>
                 <a:spcPts val="1800"/>
               </a:lnSpc>
@@ -3700,7 +4165,7 @@
                 <a:ea typeface="Roboto" pitchFamily="34" charset="-122"/>
                 <a:cs typeface="Roboto" pitchFamily="34" charset="-120"/>
               </a:rPr>
-              <a:t>Laura Sofía Posada</a:t>
+              <a:t>Jair Enrique González Buelvas</a:t>
             </a:r>
             <a:endParaRPr lang="en-US" sz="1500" dirty="0"/>
           </a:p>
@@ -3714,7 +4179,7 @@
         </p:nvSpPr>
         <p:spPr>
           <a:xfrm>
-            <a:off x="6327577" y="5479405"/>
+            <a:off x="6327577" y="5588153"/>
             <a:ext cx="4974282" cy="473125"/>
           </a:xfrm>
           <a:prstGeom prst="rect">
@@ -3724,10 +4189,10 @@
           <a:ln/>
         </p:spPr>
         <p:txBody>
-          <a:bodyPr wrap="none" lIns="0" tIns="0" rIns="0" bIns="0" rtlCol="0" anchor="ctr" vert="horz"/>
-          <a:lstStyle/>
-          <a:p>
-            <a:pPr algn="l" indent="0" marL="0">
+          <a:bodyPr vert="horz" wrap="none" lIns="0" tIns="0" rIns="0" bIns="0" rtlCol="0" anchor="ctr"/>
+          <a:lstStyle/>
+          <a:p>
+            <a:pPr marL="0" indent="0" algn="l">
               <a:lnSpc>
                 <a:spcPts val="1800"/>
               </a:lnSpc>
@@ -3742,12 +4207,11 @@
                 <a:ea typeface="Roboto" pitchFamily="34" charset="-122"/>
                 <a:cs typeface="Roboto" pitchFamily="34" charset="-120"/>
               </a:rPr>
-              <a:t>Acompañamiento institucional: Luis Eladio Porras Camargo,</a:t>
-            </a:r>
-            <a:endParaRPr lang="en-US" sz="1500" dirty="0"/>
-          </a:p>
-          <a:p>
-            <a:pPr algn="l" indent="0" marL="0">
+              <a:t>Acompañamiento institucional: </a:t>
+            </a:r>
+          </a:p>
+          <a:p>
+            <a:pPr marL="0" indent="0" algn="l">
               <a:lnSpc>
                 <a:spcPts val="1800"/>
               </a:lnSpc>
@@ -3762,6 +4226,26 @@
                 <a:ea typeface="Roboto" pitchFamily="34" charset="-122"/>
                 <a:cs typeface="Roboto" pitchFamily="34" charset="-120"/>
               </a:rPr>
+              <a:t>Luis Eladio Porras Camargo,</a:t>
+            </a:r>
+            <a:endParaRPr lang="en-US" sz="1500" dirty="0"/>
+          </a:p>
+          <a:p>
+            <a:pPr marL="0" indent="0" algn="l">
+              <a:lnSpc>
+                <a:spcPts val="1800"/>
+              </a:lnSpc>
+              <a:buNone/>
+            </a:pPr>
+            <a:r>
+              <a:rPr lang="en-US" sz="1500" dirty="0">
+                <a:solidFill>
+                  <a:srgbClr val="000000"/>
+                </a:solidFill>
+                <a:latin typeface="Roboto" pitchFamily="34" charset="0"/>
+                <a:ea typeface="Roboto" pitchFamily="34" charset="-122"/>
+                <a:cs typeface="Roboto" pitchFamily="34" charset="-120"/>
+              </a:rPr>
               <a:t>Leidy Johana Ruiz Cortés y directivos del CDMC</a:t>
             </a:r>
             <a:endParaRPr lang="en-US" sz="1500" dirty="0"/>
@@ -3786,10 +4270,10 @@
           <a:ln/>
         </p:spPr>
         <p:txBody>
-          <a:bodyPr wrap="none" lIns="0" tIns="0" rIns="0" bIns="0" rtlCol="0" anchor="ctr" vert="horz"/>
-          <a:lstStyle/>
-          <a:p>
-            <a:pPr algn="ctr" indent="0" marL="0">
+          <a:bodyPr vert="horz" wrap="none" lIns="0" tIns="0" rIns="0" bIns="0" rtlCol="0" anchor="ctr"/>
+          <a:lstStyle/>
+          <a:p>
+            <a:pPr marL="0" indent="0" algn="ctr">
               <a:buNone/>
             </a:pPr>
             <a:r>
@@ -4108,4 +4592,299 @@
     </a:ext>
   </a:extLst>
 </a:theme>
+</file>
+
+<file path=ppt/theme/theme2.xml><?xml version="1.0" encoding="utf-8"?>
+<a:theme xmlns:a="http://schemas.openxmlformats.org/drawingml/2006/main" name="Tema de Office">
+  <a:themeElements>
+    <a:clrScheme name="Office">
+      <a:dk1>
+        <a:sysClr val="windowText" lastClr="000000"/>
+      </a:dk1>
+      <a:lt1>
+        <a:sysClr val="window" lastClr="FFFFFF"/>
+      </a:lt1>
+      <a:dk2>
+        <a:srgbClr val="44546A"/>
+      </a:dk2>
+      <a:lt2>
+        <a:srgbClr val="E7E6E6"/>
+      </a:lt2>
+      <a:accent1>
+        <a:srgbClr val="4472C4"/>
+      </a:accent1>
+      <a:accent2>
+        <a:srgbClr val="ED7D31"/>
+      </a:accent2>
+      <a:accent3>
+        <a:srgbClr val="A5A5A5"/>
+      </a:accent3>
+      <a:accent4>
+        <a:srgbClr val="FFC000"/>
+      </a:accent4>
+      <a:accent5>
+        <a:srgbClr val="5B9BD5"/>
+      </a:accent5>
+      <a:accent6>
+        <a:srgbClr val="70AD47"/>
+      </a:accent6>
+      <a:hlink>
+        <a:srgbClr val="0563C1"/>
+      </a:hlink>
+      <a:folHlink>
+        <a:srgbClr val="954F72"/>
+      </a:folHlink>
+    </a:clrScheme>
+    <a:fontScheme name="Office">
+      <a:majorFont>
+        <a:latin typeface="Calibri Light" panose="020F0302020204030204"/>
+        <a:ea typeface=""/>
+        <a:cs typeface=""/>
+        <a:font script="Jpan" typeface="游ゴシック Light"/>
+        <a:font script="Hang" typeface="맑은 고딕"/>
+        <a:font script="Hans" typeface="等线 Light"/>
+        <a:font script="Hant" typeface="新細明體"/>
+        <a:font script="Arab" typeface="Times New Roman"/>
+        <a:font script="Hebr" typeface="Times New Roman"/>
+        <a:font script="Thai" typeface="Angsana New"/>
+        <a:font script="Ethi" typeface="Nyala"/>
+        <a:font script="Beng" typeface="Vrinda"/>
+        <a:font script="Gujr" typeface="Shruti"/>
+        <a:font script="Khmr" typeface="MoolBoran"/>
+        <a:font script="Knda" typeface="Tunga"/>
+        <a:font script="Guru" typeface="Raavi"/>
+        <a:font script="Cans" typeface="Euphemia"/>
+        <a:font script="Cher" typeface="Plantagenet Cherokee"/>
+        <a:font script="Yiii" typeface="Microsoft Yi Baiti"/>
+        <a:font script="Tibt" typeface="Microsoft Himalaya"/>
+        <a:font script="Thaa" typeface="MV Boli"/>
+        <a:font script="Deva" typeface="Mangal"/>
+        <a:font script="Telu" typeface="Gautami"/>
+        <a:font script="Taml" typeface="Latha"/>
+        <a:font script="Syrc" typeface="Estrangelo Edessa"/>
+        <a:font script="Orya" typeface="Kalinga"/>
+        <a:font script="Mlym" typeface="Kartika"/>
+        <a:font script="Laoo" typeface="DokChampa"/>
+        <a:font script="Sinh" typeface="Iskoola Pota"/>
+        <a:font script="Mong" typeface="Mongolian Baiti"/>
+        <a:font script="Viet" typeface="Times New Roman"/>
+        <a:font script="Uigh" typeface="Microsoft Uighur"/>
+        <a:font script="Geor" typeface="Sylfaen"/>
+        <a:font script="Armn" typeface="Arial"/>
+        <a:font script="Bugi" typeface="Leelawadee UI"/>
+        <a:font script="Bopo" typeface="Microsoft JhengHei"/>
+        <a:font script="Java" typeface="Javanese Text"/>
+        <a:font script="Lisu" typeface="Segoe UI"/>
+        <a:font script="Mymr" typeface="Myanmar Text"/>
+        <a:font script="Nkoo" typeface="Ebrima"/>
+        <a:font script="Olck" typeface="Nirmala UI"/>
+        <a:font script="Osma" typeface="Ebrima"/>
+        <a:font script="Phag" typeface="Phagspa"/>
+        <a:font script="Syrn" typeface="Estrangelo Edessa"/>
+        <a:font script="Syrj" typeface="Estrangelo Edessa"/>
+        <a:font script="Syre" typeface="Estrangelo Edessa"/>
+        <a:font script="Sora" typeface="Nirmala UI"/>
+        <a:font script="Tale" typeface="Microsoft Tai Le"/>
+        <a:font script="Talu" typeface="Microsoft New Tai Lue"/>
+        <a:font script="Tfng" typeface="Ebrima"/>
+      </a:majorFont>
+      <a:minorFont>
+        <a:latin typeface="Calibri" panose="020F0502020204030204"/>
+        <a:ea typeface=""/>
+        <a:cs typeface=""/>
+        <a:font script="Jpan" typeface="游ゴシック"/>
+        <a:font script="Hang" typeface="맑은 고딕"/>
+        <a:font script="Hans" typeface="等线"/>
+        <a:font script="Hant" typeface="新細明體"/>
+        <a:font script="Arab" typeface="Arial"/>
+        <a:font script="Hebr" typeface="Arial"/>
+        <a:font script="Thai" typeface="Cordia New"/>
+        <a:font script="Ethi" typeface="Nyala"/>
+        <a:font script="Beng" typeface="Vrinda"/>
+        <a:font script="Gujr" typeface="Shruti"/>
+        <a:font script="Khmr" typeface="DaunPenh"/>
+        <a:font script="Knda" typeface="Tunga"/>
+        <a:font script="Guru" typeface="Raavi"/>
+        <a:font script="Cans" typeface="Euphemia"/>
+        <a:font script="Cher" typeface="Plantagenet Cherokee"/>
+        <a:font script="Yiii" typeface="Microsoft Yi Baiti"/>
+        <a:font script="Tibt" typeface="Microsoft Himalaya"/>
+        <a:font script="Thaa" typeface="MV Boli"/>
+        <a:font script="Deva" typeface="Mangal"/>
+        <a:font script="Telu" typeface="Gautami"/>
+        <a:font script="Taml" typeface="Latha"/>
+        <a:font script="Syrc" typeface="Estrangelo Edessa"/>
+        <a:font script="Orya" typeface="Kalinga"/>
+        <a:font script="Mlym" typeface="Kartika"/>
+        <a:font script="Laoo" typeface="DokChampa"/>
+        <a:font script="Sinh" typeface="Iskoola Pota"/>
+        <a:font script="Mong" typeface="Mongolian Baiti"/>
+        <a:font script="Viet" typeface="Arial"/>
+        <a:font script="Uigh" typeface="Microsoft Uighur"/>
+        <a:font script="Geor" typeface="Sylfaen"/>
+        <a:font script="Armn" typeface="Arial"/>
+        <a:font script="Bugi" typeface="Leelawadee UI"/>
+        <a:font script="Bopo" typeface="Microsoft JhengHei"/>
+        <a:font script="Java" typeface="Javanese Text"/>
+        <a:font script="Lisu" typeface="Segoe UI"/>
+        <a:font script="Mymr" typeface="Myanmar Text"/>
+        <a:font script="Nkoo" typeface="Ebrima"/>
+        <a:font script="Olck" typeface="Nirmala UI"/>
+        <a:font script="Osma" typeface="Ebrima"/>
+        <a:font script="Phag" typeface="Phagspa"/>
+        <a:font script="Syrn" typeface="Estrangelo Edessa"/>
+        <a:font script="Syrj" typeface="Estrangelo Edessa"/>
+        <a:font script="Syre" typeface="Estrangelo Edessa"/>
+        <a:font script="Sora" typeface="Nirmala UI"/>
+        <a:font script="Tale" typeface="Microsoft Tai Le"/>
+        <a:font script="Talu" typeface="Microsoft New Tai Lue"/>
+        <a:font script="Tfng" typeface="Ebrima"/>
+      </a:minorFont>
+    </a:fontScheme>
+    <a:fmtScheme name="Office">
+      <a:fillStyleLst>
+        <a:solidFill>
+          <a:schemeClr val="phClr"/>
+        </a:solidFill>
+        <a:gradFill rotWithShape="1">
+          <a:gsLst>
+            <a:gs pos="0">
+              <a:schemeClr val="phClr">
+                <a:lumMod val="110000"/>
+                <a:satMod val="105000"/>
+                <a:tint val="67000"/>
+              </a:schemeClr>
+            </a:gs>
+            <a:gs pos="50000">
+              <a:schemeClr val="phClr">
+                <a:lumMod val="105000"/>
+                <a:satMod val="103000"/>
+                <a:tint val="73000"/>
+              </a:schemeClr>
+            </a:gs>
+            <a:gs pos="100000">
+              <a:schemeClr val="phClr">
+                <a:lumMod val="105000"/>
+                <a:satMod val="109000"/>
+                <a:tint val="81000"/>
+              </a:schemeClr>
+            </a:gs>
+          </a:gsLst>
+          <a:lin ang="5400000" scaled="0"/>
+        </a:gradFill>
+        <a:gradFill rotWithShape="1">
+          <a:gsLst>
+            <a:gs pos="0">
+              <a:schemeClr val="phClr">
+                <a:satMod val="103000"/>
+                <a:lumMod val="102000"/>
+                <a:tint val="94000"/>
+              </a:schemeClr>
+            </a:gs>
+            <a:gs pos="50000">
+              <a:schemeClr val="phClr">
+                <a:satMod val="110000"/>
+                <a:lumMod val="100000"/>
+                <a:shade val="100000"/>
+              </a:schemeClr>
+            </a:gs>
+            <a:gs pos="100000">
+              <a:schemeClr val="phClr">
+                <a:lumMod val="99000"/>
+                <a:satMod val="120000"/>
+                <a:shade val="78000"/>
+              </a:schemeClr>
+            </a:gs>
+          </a:gsLst>
+          <a:lin ang="5400000" scaled="0"/>
+        </a:gradFill>
+      </a:fillStyleLst>
+      <a:lnStyleLst>
+        <a:ln w="6350" cap="flat" cmpd="sng" algn="ctr">
+          <a:solidFill>
+            <a:schemeClr val="phClr"/>
+          </a:solidFill>
+          <a:prstDash val="solid"/>
+          <a:miter lim="800000"/>
+        </a:ln>
+        <a:ln w="12700" cap="flat" cmpd="sng" algn="ctr">
+          <a:solidFill>
+            <a:schemeClr val="phClr"/>
+          </a:solidFill>
+          <a:prstDash val="solid"/>
+          <a:miter lim="800000"/>
+        </a:ln>
+        <a:ln w="19050" cap="flat" cmpd="sng" algn="ctr">
+          <a:solidFill>
+            <a:schemeClr val="phClr"/>
+          </a:solidFill>
+          <a:prstDash val="solid"/>
+          <a:miter lim="800000"/>
+        </a:ln>
+      </a:lnStyleLst>
+      <a:effectStyleLst>
+        <a:effectStyle>
+          <a:effectLst/>
+        </a:effectStyle>
+        <a:effectStyle>
+          <a:effectLst/>
+        </a:effectStyle>
+        <a:effectStyle>
+          <a:effectLst>
+            <a:outerShdw blurRad="57150" dist="19050" dir="5400000" algn="ctr" rotWithShape="0">
+              <a:srgbClr val="000000">
+                <a:alpha val="63000"/>
+              </a:srgbClr>
+            </a:outerShdw>
+          </a:effectLst>
+        </a:effectStyle>
+      </a:effectStyleLst>
+      <a:bgFillStyleLst>
+        <a:solidFill>
+          <a:schemeClr val="phClr"/>
+        </a:solidFill>
+        <a:solidFill>
+          <a:schemeClr val="phClr">
+            <a:tint val="95000"/>
+            <a:satMod val="170000"/>
+          </a:schemeClr>
+        </a:solidFill>
+        <a:gradFill rotWithShape="1">
+          <a:gsLst>
+            <a:gs pos="0">
+              <a:schemeClr val="phClr">
+                <a:tint val="93000"/>
+                <a:satMod val="150000"/>
+                <a:shade val="98000"/>
+                <a:lumMod val="102000"/>
+              </a:schemeClr>
+            </a:gs>
+            <a:gs pos="50000">
+              <a:schemeClr val="phClr">
+                <a:tint val="98000"/>
+                <a:satMod val="130000"/>
+                <a:shade val="90000"/>
+                <a:lumMod val="103000"/>
+              </a:schemeClr>
+            </a:gs>
+            <a:gs pos="100000">
+              <a:schemeClr val="phClr">
+                <a:shade val="63000"/>
+                <a:satMod val="120000"/>
+              </a:schemeClr>
+            </a:gs>
+          </a:gsLst>
+          <a:lin ang="5400000" scaled="0"/>
+        </a:gradFill>
+      </a:bgFillStyleLst>
+    </a:fmtScheme>
+  </a:themeElements>
+  <a:objectDefaults/>
+  <a:extraClrSchemeLst/>
+  <a:extLst>
+    <a:ext uri="{05A4C25C-085E-4340-85A3-A5531E510DB2}">
+      <thm15:themeFamily xmlns:thm15="http://schemas.microsoft.com/office/thememl/2012/main" name="Office Theme" id="{62F939B6-93AF-4DB8-9C6B-D6C7DFDC589F}" vid="{4A3C46E8-61CC-4603-A589-7422A47A8E4A}"/>
+    </a:ext>
+  </a:extLst>
+</a:theme>
 </file>
</xml_diff>